<commit_message>
Condense final deck to 5 slides
1. Title + executive summary (the answer: 82% movers, structural churn)
2. Data & approach + headline charts
3. Why customers leave — reasons + contract & competition (OR table)
4. Where/what/when — geography, bundle, timing
5. UK fibre market context + prescriptive recommendations

Co-Authored-By: Devin AI <158243242+devin-ai-integration[bot]@users.noreply.github.com>
</commit_message>
<xml_diff>
--- a/presentation/Churn_Analysis_Final.pptx
+++ b/presentation/Churn_Analysis_Final.pptx
@@ -10,12 +10,6 @@
     <p:sldId id="258" r:id="rId9"/>
     <p:sldId id="259" r:id="rId10"/>
     <p:sldId id="260" r:id="rId11"/>
-    <p:sldId id="261" r:id="rId12"/>
-    <p:sldId id="262" r:id="rId13"/>
-    <p:sldId id="263" r:id="rId14"/>
-    <p:sldId id="264" r:id="rId15"/>
-    <p:sldId id="265" r:id="rId16"/>
-    <p:sldId id="266" r:id="rId17"/>
   </p:sldIdLst>
   <p:sldSz cx="12188952" cy="6858000" type="screen4x3"/>
   <p:notesSz cx="6858000" cy="9144000"/>
@@ -3106,83 +3100,6 @@
         </p:nvSpPr>
         <p:spPr>
           <a:xfrm>
-            <a:off x="822960" y="2011680"/>
-            <a:ext cx="10515600" cy="2011680"/>
-          </a:xfrm>
-          <a:prstGeom prst="rect">
-            <a:avLst/>
-          </a:prstGeom>
-          <a:noFill/>
-        </p:spPr>
-        <p:txBody>
-          <a:bodyPr wrap="square">
-            <a:spAutoFit/>
-          </a:bodyPr>
-          <a:lstStyle/>
-          <a:p>
-            <a:pPr>
-              <a:defRPr sz="4400" b="1">
-                <a:solidFill>
-                  <a:srgbClr val="1F4E79"/>
-                </a:solidFill>
-              </a:defRPr>
-            </a:pPr>
-            <a:r>
-              <a:t>Why our customers leave</a:t>
-            </a:r>
-          </a:p>
-          <a:p>
-            <a:pPr>
-              <a:defRPr sz="2000">
-                <a:solidFill>
-                  <a:srgbClr val="222222"/>
-                </a:solidFill>
-              </a:defRPr>
-            </a:pPr>
-            <a:r>
-              <a:t>Churn analysis — UK full-fibre broadband · customer base of 10,000 records</a:t>
-            </a:r>
-          </a:p>
-          <a:p>
-            <a:pPr>
-              <a:defRPr sz="1400">
-                <a:solidFill>
-                  <a:srgbClr val="222222"/>
-                </a:solidFill>
-              </a:defRPr>
-            </a:pPr>
-            <a:r>
-              <a:t>Prepared for business stakeholders · descriptive, predictive and prescriptive analytics</a:t>
-            </a:r>
-          </a:p>
-        </p:txBody>
-      </p:sp>
-    </p:spTree>
-  </p:cSld>
-  <p:clrMapOvr>
-    <a:masterClrMapping/>
-  </p:clrMapOvr>
-</p:sld>
-</file>
-
-<file path=ppt/slides/slide10.xml><?xml version="1.0" encoding="utf-8"?>
-<p:sld xmlns:a="http://schemas.openxmlformats.org/drawingml/2006/main" xmlns:p="http://schemas.openxmlformats.org/presentationml/2006/main" xmlns:r="http://schemas.openxmlformats.org/officeDocument/2006/relationships">
-  <p:cSld>
-    <p:spTree>
-      <p:nvGrpSpPr>
-        <p:cNvPr id="1" name=""/>
-        <p:cNvGrpSpPr/>
-        <p:nvPr/>
-      </p:nvGrpSpPr>
-      <p:grpSpPr/>
-      <p:sp>
-        <p:nvSpPr>
-          <p:cNvPr id="2" name="TextBox 1"/>
-          <p:cNvSpPr txBox="1"/>
-          <p:nvPr/>
-        </p:nvSpPr>
-        <p:spPr>
-          <a:xfrm>
             <a:off x="457200" y="228600"/>
             <a:ext cx="11247120" cy="640080"/>
           </a:xfrm>
@@ -3205,7 +3122,7 @@
               </a:defRPr>
             </a:pPr>
             <a:r>
-              <a:t>UK fibre market context — why this matters</a:t>
+              <a:t>Why our customers leave</a:t>
             </a:r>
           </a:p>
         </p:txBody>
@@ -3218,7 +3135,42 @@
         </p:nvSpPr>
         <p:spPr>
           <a:xfrm>
-            <a:off x="457200" y="1051560"/>
+            <a:off x="457200" y="777240"/>
+            <a:ext cx="11247120" cy="365760"/>
+          </a:xfrm>
+          <a:prstGeom prst="rect">
+            <a:avLst/>
+          </a:prstGeom>
+          <a:noFill/>
+        </p:spPr>
+        <p:txBody>
+          <a:bodyPr wrap="none">
+            <a:spAutoFit/>
+          </a:bodyPr>
+          <a:lstStyle/>
+          <a:p>
+            <a:pPr>
+              <a:defRPr sz="1300" i="1">
+                <a:solidFill>
+                  <a:srgbClr val="222222"/>
+                </a:solidFill>
+              </a:defRPr>
+            </a:pPr>
+            <a:r>
+              <a:t>Churn analysis · UK full-fibre broadband · 10,000 customer records · descriptive → predictive → prescriptive</a:t>
+            </a:r>
+          </a:p>
+        </p:txBody>
+      </p:sp>
+      <p:sp>
+        <p:nvSpPr>
+          <p:cNvPr id="4" name="TextBox 3"/>
+          <p:cNvSpPr txBox="1"/>
+          <p:nvPr/>
+        </p:nvSpPr>
+        <p:spPr>
+          <a:xfrm>
+            <a:off x="457200" y="1371600"/>
             <a:ext cx="11247120" cy="5394960"/>
           </a:xfrm>
           <a:prstGeom prst="rect">
@@ -3234,7 +3186,7 @@
           <a:p>
             <a:pPr>
               <a:spcAft>
-                <a:spcPts val="1000"/>
+                <a:spcPts val="900"/>
               </a:spcAft>
             </a:pPr>
             <a:r>
@@ -3243,7 +3195,7 @@
                   <a:srgbClr val="1F4E79"/>
                 </a:solidFill>
               </a:rPr>
-              <a:t>•  Altnet overbuild</a:t>
+              <a:t>•  The answer in one line</a:t>
             </a:r>
             <a:r>
               <a:rPr sz="1500" b="0">
@@ -3251,13 +3203,13 @@
                   <a:srgbClr val="222222"/>
                 </a:solidFill>
               </a:rPr>
-              <a:t>  —  the UK altnet sector (incl. Hyperoptic) grew fast, often overbuilding the same dense postcodes — when a mover's new address sits on another network, churn is automatic, not competitive loss.</a:t>
+              <a:t>  —  most churn is structural, not dissatisfaction: 82% of terminations are customers moving home or leaving the area — where our network may not reach.</a:t>
             </a:r>
           </a:p>
           <a:p>
             <a:pPr>
               <a:spcAft>
-                <a:spcPts val="1000"/>
+                <a:spcPts val="900"/>
               </a:spcAft>
             </a:pPr>
             <a:r>
@@ -3266,7 +3218,7 @@
                   <a:srgbClr val="1F4E79"/>
                 </a:solidFill>
               </a:rPr>
-              <a:t>•  Price pressure</a:t>
+              <a:t>•  Recorded churn</a:t>
             </a:r>
             <a:r>
               <a:rPr sz="1500" b="0">
@@ -3274,13 +3226,13 @@
                   <a:srgbClr val="222222"/>
                 </a:solidFill>
               </a:rPr>
-              <a:t>  —  wholesale FTTP prices fell ~40% in real terms over the build-out period — retention via contract length beats price wars.</a:t>
+              <a:t>  —  6,947 of 10,000 customers (69.5%) terminated; the base is churn-weighted, so treat rates as relative comparisons, not the live-business rate.</a:t>
             </a:r>
           </a:p>
           <a:p>
             <a:pPr>
               <a:spcAft>
-                <a:spcPts val="1000"/>
+                <a:spcPts val="900"/>
               </a:spcAft>
             </a:pPr>
             <a:r>
@@ -3289,7 +3241,7 @@
                   <a:srgbClr val="1F4E79"/>
                 </a:solidFill>
               </a:rPr>
-              <a:t>•  Consolidation wave</a:t>
+              <a:t>•  Strongest controllable lever</a:t>
             </a:r>
             <a:r>
               <a:rPr sz="1500" b="0">
@@ -3297,13 +3249,13 @@
                   <a:srgbClr val="222222"/>
                 </a:solidFill>
               </a:rPr>
-              <a:t>  —  altnets are consolidating (debt-funded build-out + missed take-up targets); keeping existing customers is far cheaper than the market's rising acquisition costs.</a:t>
+              <a:t>  —  24-month contracts churn at 42.5% vs ~75% for monthly/12-month — 78% lower odds of churn after controls.</a:t>
             </a:r>
           </a:p>
           <a:p>
             <a:pPr>
               <a:spcAft>
-                <a:spcPts val="1000"/>
+                <a:spcPts val="900"/>
               </a:spcAft>
             </a:pPr>
             <a:r>
@@ -3312,7 +3264,7 @@
                   <a:srgbClr val="1F4E79"/>
                 </a:solidFill>
               </a:rPr>
-              <a:t>•  Read on our data</a:t>
+              <a:t>•  Geography</a:t>
             </a:r>
             <a:r>
               <a:rPr sz="1500" b="0">
@@ -3320,89 +3272,13 @@
                   <a:srgbClr val="222222"/>
                 </a:solidFill>
               </a:rPr>
-              <a:t>  —  competitor count not being significant + mover-dominated reasons support the structural view: the fight is coverage and contracts, not head-to-head pricing.</a:t>
-            </a:r>
-          </a:p>
-        </p:txBody>
-      </p:sp>
-    </p:spTree>
-  </p:cSld>
-  <p:clrMapOvr>
-    <a:masterClrMapping/>
-  </p:clrMapOvr>
-</p:sld>
-</file>
-
-<file path=ppt/slides/slide11.xml><?xml version="1.0" encoding="utf-8"?>
-<p:sld xmlns:a="http://schemas.openxmlformats.org/drawingml/2006/main" xmlns:p="http://schemas.openxmlformats.org/presentationml/2006/main" xmlns:r="http://schemas.openxmlformats.org/officeDocument/2006/relationships">
-  <p:cSld>
-    <p:spTree>
-      <p:nvGrpSpPr>
-        <p:cNvPr id="1" name=""/>
-        <p:cNvGrpSpPr/>
-        <p:nvPr/>
-      </p:nvGrpSpPr>
-      <p:grpSpPr/>
-      <p:sp>
-        <p:nvSpPr>
-          <p:cNvPr id="2" name="TextBox 1"/>
-          <p:cNvSpPr txBox="1"/>
-          <p:nvPr/>
-        </p:nvSpPr>
-        <p:spPr>
-          <a:xfrm>
-            <a:off x="457200" y="228600"/>
-            <a:ext cx="11247120" cy="640080"/>
-          </a:xfrm>
-          <a:prstGeom prst="rect">
-            <a:avLst/>
-          </a:prstGeom>
-          <a:noFill/>
-        </p:spPr>
-        <p:txBody>
-          <a:bodyPr wrap="none">
-            <a:spAutoFit/>
-          </a:bodyPr>
-          <a:lstStyle/>
-          <a:p>
-            <a:pPr>
-              <a:defRPr sz="2800" b="1">
-                <a:solidFill>
-                  <a:srgbClr val="1F4E79"/>
-                </a:solidFill>
-              </a:defRPr>
-            </a:pPr>
-            <a:r>
-              <a:t>Recommendations — prescriptive</a:t>
-            </a:r>
-          </a:p>
-        </p:txBody>
-      </p:sp>
-      <p:sp>
-        <p:nvSpPr>
-          <p:cNvPr id="3" name="TextBox 2"/>
-          <p:cNvSpPr txBox="1"/>
-          <p:nvPr/>
-        </p:nvSpPr>
-        <p:spPr>
-          <a:xfrm>
-            <a:off x="457200" y="1051560"/>
-            <a:ext cx="11247120" cy="5394960"/>
-          </a:xfrm>
-          <a:prstGeom prst="rect">
-            <a:avLst/>
-          </a:prstGeom>
-          <a:noFill/>
-        </p:spPr>
-        <p:txBody>
-          <a:bodyPr wrap="square">
-            <a:spAutoFit/>
-          </a:bodyPr>
-          <a:lstStyle/>
+              <a:t>  —  Leeds (82%) and Manchester (77%) churn well above London (63%) and Nottingham (41%).</a:t>
+            </a:r>
+          </a:p>
           <a:p>
             <a:pPr>
               <a:spcAft>
-                <a:spcPts val="1000"/>
+                <a:spcPts val="900"/>
               </a:spcAft>
             </a:pPr>
             <a:r>
@@ -3411,7 +3287,7 @@
                   <a:srgbClr val="1F4E79"/>
                 </a:solidFill>
               </a:rPr>
-              <a:t>•  1. Contract migration</a:t>
+              <a:t>•  Competition is NOT the driver</a:t>
             </a:r>
             <a:r>
               <a:rPr sz="1500" b="0">
@@ -3419,13 +3295,13 @@
                   <a:srgbClr val="222222"/>
                 </a:solidFill>
               </a:rPr>
-              <a:t>  —  move monthly/12-month customers to 24-month terms at renewal — biggest controllable effect (OR 0.22).</a:t>
+              <a:t>  —  number of competitors has no significant effect once other factors are controlled — spend on contract terms and movers, not price matching.</a:t>
             </a:r>
           </a:p>
           <a:p>
             <a:pPr>
               <a:spcAft>
-                <a:spcPts val="1000"/>
+                <a:spcPts val="900"/>
               </a:spcAft>
             </a:pPr>
             <a:r>
@@ -3434,7 +3310,7 @@
                   <a:srgbClr val="1F4E79"/>
                 </a:solidFill>
               </a:rPr>
-              <a:t>•  2. Mover's programme</a:t>
+              <a:t>•  What to do</a:t>
             </a:r>
             <a:r>
               <a:rPr sz="1500" b="0">
@@ -3442,99 +3318,7 @@
                   <a:srgbClr val="222222"/>
                 </a:solidFill>
               </a:rPr>
-              <a:t>  —  82% of churn is relocation: seamless home-move transfers + landlord/developer partnerships keep movers on-network.</a:t>
-            </a:r>
-          </a:p>
-          <a:p>
-            <a:pPr>
-              <a:spcAft>
-                <a:spcPts val="1000"/>
-              </a:spcAft>
-            </a:pPr>
-            <a:r>
-              <a:rPr sz="1500" b="1">
-                <a:solidFill>
-                  <a:srgbClr val="1F4E79"/>
-                </a:solidFill>
-              </a:rPr>
-              <a:t>•  3. Manchester &amp; Leeds review</a:t>
-            </a:r>
-            <a:r>
-              <a:rPr sz="1500" b="0">
-                <a:solidFill>
-                  <a:srgbClr val="222222"/>
-                </a:solidFill>
-              </a:rPr>
-              <a:t>  —  highest churn rates — local service quality, install experience, overbuild pressure.</a:t>
-            </a:r>
-          </a:p>
-          <a:p>
-            <a:pPr>
-              <a:spcAft>
-                <a:spcPts val="1000"/>
-              </a:spcAft>
-            </a:pPr>
-            <a:r>
-              <a:rPr sz="1500" b="1">
-                <a:solidFill>
-                  <a:srgbClr val="1F4E79"/>
-                </a:solidFill>
-              </a:rPr>
-              <a:t>•  4. Entry-tier upgrade path</a:t>
-            </a:r>
-            <a:r>
-              <a:rPr sz="1500" b="0">
-                <a:solidFill>
-                  <a:srgbClr val="222222"/>
-                </a:solidFill>
-              </a:rPr>
-              <a:t>  —  50Mb bundle churns most (82%) — nudge toward higher tiers.</a:t>
-            </a:r>
-          </a:p>
-          <a:p>
-            <a:pPr>
-              <a:spcAft>
-                <a:spcPts val="1000"/>
-              </a:spcAft>
-            </a:pPr>
-            <a:r>
-              <a:rPr sz="1500" b="1">
-                <a:solidFill>
-                  <a:srgbClr val="1F4E79"/>
-                </a:solidFill>
-              </a:rPr>
-              <a:t>•  5. Deploy the model</a:t>
-            </a:r>
-            <a:r>
-              <a:rPr sz="1500" b="0">
-                <a:solidFill>
-                  <a:srgbClr val="222222"/>
-                </a:solidFill>
-              </a:rPr>
-              <a:t>  —  score active customers in CRM (dashboard calculator already live) and trigger offers above a risk threshold.</a:t>
-            </a:r>
-          </a:p>
-          <a:p>
-            <a:pPr>
-              <a:spcAft>
-                <a:spcPts val="1000"/>
-              </a:spcAft>
-            </a:pPr>
-            <a:r>
-              <a:rPr sz="1500" b="1">
-                <a:solidFill>
-                  <a:srgbClr val="1F4E79"/>
-                </a:solidFill>
-              </a:rPr>
-              <a:t>•  6. Better churn reporting</a:t>
-            </a:r>
-            <a:r>
-              <a:rPr sz="1500" b="0">
-                <a:solidFill>
-                  <a:srgbClr val="222222"/>
-                </a:solidFill>
-              </a:rPr>
-              <a:t>  —  report survival/exposure-based churn; clarify the 'Customer not leaving' category.</a:t>
+              <a:t>  —  contract migration at renewal, a mover's programme, and a Manchester/Leeds service-quality review — recommendations on the last slide.</a:t>
             </a:r>
           </a:p>
         </p:txBody>
@@ -3587,7 +3371,7 @@
               </a:defRPr>
             </a:pPr>
             <a:r>
-              <a:t>Executive summary — why customers leave</a:t>
+              <a:t>Data, approach &amp; headline findings</a:t>
             </a:r>
           </a:p>
         </p:txBody>
@@ -3600,8 +3384,8 @@
         </p:nvSpPr>
         <p:spPr>
           <a:xfrm>
-            <a:off x="457200" y="1051560"/>
-            <a:ext cx="11247120" cy="5394960"/>
+            <a:off x="457200" y="914400"/>
+            <a:ext cx="11247120" cy="1463040"/>
           </a:xfrm>
           <a:prstGeom prst="rect">
             <a:avLst/>
@@ -3616,143 +3400,147 @@
           <a:p>
             <a:pPr>
               <a:spcAft>
-                <a:spcPts val="1000"/>
+                <a:spcPts val="900"/>
               </a:spcAft>
             </a:pPr>
             <a:r>
-              <a:rPr sz="1500" b="1">
+              <a:rPr sz="1200" b="1">
                 <a:solidFill>
                   <a:srgbClr val="1F4E79"/>
                 </a:solidFill>
               </a:rPr>
-              <a:t>•  The answer in one line</a:t>
-            </a:r>
-            <a:r>
-              <a:rPr sz="1500" b="0">
+              <a:t>•  Data</a:t>
+            </a:r>
+            <a:r>
+              <a:rPr sz="1200" b="0">
                 <a:solidFill>
                   <a:srgbClr val="222222"/>
                 </a:solidFill>
               </a:rPr>
-              <a:t>  —  most churn is structural, not dissatisfaction: 82% of terminations are customers moving home or leaving the area — where our network may not reach.</a:t>
+              <a:t>  —  10,000 customers · activations Jan 2020 – Dec 2024 · terminations to Sep 2025. Cleaning: serial dates parsed, '-' → missing; only termination fields are missing — missing termination = still active.</a:t>
             </a:r>
           </a:p>
           <a:p>
             <a:pPr>
               <a:spcAft>
-                <a:spcPts val="1000"/>
+                <a:spcPts val="900"/>
               </a:spcAft>
             </a:pPr>
             <a:r>
-              <a:rPr sz="1500" b="1">
+              <a:rPr sz="1200" b="1">
                 <a:solidFill>
                   <a:srgbClr val="1F4E79"/>
                 </a:solidFill>
               </a:rPr>
-              <a:t>•  Recorded churn</a:t>
-            </a:r>
-            <a:r>
-              <a:rPr sz="1500" b="0">
+              <a:t>•  Approach</a:t>
+            </a:r>
+            <a:r>
+              <a:rPr sz="1200" b="0">
                 <a:solidFill>
                   <a:srgbClr val="222222"/>
                 </a:solidFill>
               </a:rPr>
-              <a:t>  —  6,947 of 10,000 customers (69.5%) terminated; the base is churn-weighted, so treat rates as relative comparisons, not the live-business rate.</a:t>
-            </a:r>
-          </a:p>
-          <a:p>
-            <a:pPr>
-              <a:spcAft>
-                <a:spcPts val="1000"/>
-              </a:spcAft>
-            </a:pPr>
-            <a:r>
-              <a:rPr sz="1500" b="1">
-                <a:solidFill>
-                  <a:srgbClr val="1F4E79"/>
-                </a:solidFill>
-              </a:rPr>
-              <a:t>•  The strongest lever is contract structure</a:t>
-            </a:r>
-            <a:r>
-              <a:rPr sz="1500" b="0">
-                <a:solidFill>
-                  <a:srgbClr val="222222"/>
-                </a:solidFill>
-              </a:rPr>
-              <a:t>  —  24-month contracts churn at 42.5% vs ~75% for monthly/12-month — 78% lower odds of churn after controls.</a:t>
-            </a:r>
-          </a:p>
-          <a:p>
-            <a:pPr>
-              <a:spcAft>
-                <a:spcPts val="1000"/>
-              </a:spcAft>
-            </a:pPr>
-            <a:r>
-              <a:rPr sz="1500" b="1">
-                <a:solidFill>
-                  <a:srgbClr val="1F4E79"/>
-                </a:solidFill>
-              </a:rPr>
-              <a:t>•  Geography matters</a:t>
-            </a:r>
-            <a:r>
-              <a:rPr sz="1500" b="0">
-                <a:solidFill>
-                  <a:srgbClr val="222222"/>
-                </a:solidFill>
-              </a:rPr>
-              <a:t>  —  Leeds (82%) and Manchester (77%) churn well above London (63%) and Nottingham (41%).</a:t>
-            </a:r>
-          </a:p>
-          <a:p>
-            <a:pPr>
-              <a:spcAft>
-                <a:spcPts val="1000"/>
-              </a:spcAft>
-            </a:pPr>
-            <a:r>
-              <a:rPr sz="1500" b="1">
-                <a:solidFill>
-                  <a:srgbClr val="1F4E79"/>
-                </a:solidFill>
-              </a:rPr>
-              <a:t>•  Competition is NOT the driver</a:t>
-            </a:r>
-            <a:r>
-              <a:rPr sz="1500" b="0">
-                <a:solidFill>
-                  <a:srgbClr val="222222"/>
-                </a:solidFill>
-              </a:rPr>
-              <a:t>  —  number of competitors present has no significant effect once other factors are controlled — retention spend should target contract terms and movers, not price matching.</a:t>
-            </a:r>
-          </a:p>
-          <a:p>
-            <a:pPr>
-              <a:spcAft>
-                <a:spcPts val="1000"/>
-              </a:spcAft>
-            </a:pPr>
-            <a:r>
-              <a:rPr sz="1500" b="1">
-                <a:solidFill>
-                  <a:srgbClr val="1F4E79"/>
-                </a:solidFill>
-              </a:rPr>
-              <a:t>•  What to do</a:t>
-            </a:r>
-            <a:r>
-              <a:rPr sz="1500" b="0">
-                <a:solidFill>
-                  <a:srgbClr val="222222"/>
-                </a:solidFill>
-              </a:rPr>
-              <a:t>  —  contract migration at renewal, a mover's programme, and Manchester/Leeds service-quality review — recommendations on the last slide.</a:t>
-            </a:r>
-          </a:p>
-        </p:txBody>
-      </p:sp>
+              <a:t>  —  descriptive → statistics (chi-square, Cramér's V, correlations) → logistic regression (interpretable odds ratios; holdout acc 78%, AUC 0.80, recall 89%).</a:t>
+            </a:r>
+          </a:p>
+        </p:txBody>
+      </p:sp>
+      <p:pic>
+        <p:nvPicPr>
+          <p:cNvPr id="4" name="Picture 3" descr="nb_contract_churn.png"/>
+          <p:cNvPicPr>
+            <a:picLocks noChangeAspect="1"/>
+          </p:cNvPicPr>
+          <p:nvPr/>
+        </p:nvPicPr>
+        <p:blipFill>
+          <a:blip r:embed="rId2"/>
+          <a:stretch>
+            <a:fillRect/>
+          </a:stretch>
+        </p:blipFill>
+        <p:spPr>
+          <a:xfrm>
+            <a:off x="274320" y="2468880"/>
+            <a:ext cx="5669280" cy="3505624"/>
+          </a:xfrm>
+          <a:prstGeom prst="rect">
+            <a:avLst/>
+          </a:prstGeom>
+        </p:spPr>
+      </p:pic>
+      <p:pic>
+        <p:nvPicPr>
+          <p:cNvPr id="5" name="Picture 4" descr="nb_city_churn.png"/>
+          <p:cNvPicPr>
+            <a:picLocks noChangeAspect="1"/>
+          </p:cNvPicPr>
+          <p:nvPr/>
+        </p:nvPicPr>
+        <p:blipFill>
+          <a:blip r:embed="rId3"/>
+          <a:stretch>
+            <a:fillRect/>
+          </a:stretch>
+        </p:blipFill>
+        <p:spPr>
+          <a:xfrm>
+            <a:off x="6217920" y="2468880"/>
+            <a:ext cx="5669280" cy="3507845"/>
+          </a:xfrm>
+          <a:prstGeom prst="rect">
+            <a:avLst/>
+          </a:prstGeom>
+        </p:spPr>
+      </p:pic>
+      <p:pic>
+        <p:nvPicPr>
+          <p:cNvPr id="6" name="Picture 5" descr="nb_bundle_churn_all.png"/>
+          <p:cNvPicPr>
+            <a:picLocks noChangeAspect="1"/>
+          </p:cNvPicPr>
+          <p:nvPr/>
+        </p:nvPicPr>
+        <p:blipFill>
+          <a:blip r:embed="rId4"/>
+          <a:stretch>
+            <a:fillRect/>
+          </a:stretch>
+        </p:blipFill>
+        <p:spPr>
+          <a:xfrm>
+            <a:off x="274320" y="4892040"/>
+            <a:ext cx="5669280" cy="3505624"/>
+          </a:xfrm>
+          <a:prstGeom prst="rect">
+            <a:avLst/>
+          </a:prstGeom>
+        </p:spPr>
+      </p:pic>
+      <p:pic>
+        <p:nvPicPr>
+          <p:cNvPr id="7" name="Picture 6" descr="nb_cohort_churn.png"/>
+          <p:cNvPicPr>
+            <a:picLocks noChangeAspect="1"/>
+          </p:cNvPicPr>
+          <p:nvPr/>
+        </p:nvPicPr>
+        <p:blipFill>
+          <a:blip r:embed="rId5"/>
+          <a:stretch>
+            <a:fillRect/>
+          </a:stretch>
+        </p:blipFill>
+        <p:spPr>
+          <a:xfrm>
+            <a:off x="6217920" y="4892040"/>
+            <a:ext cx="5669280" cy="3505624"/>
+          </a:xfrm>
+          <a:prstGeom prst="rect">
+            <a:avLst/>
+          </a:prstGeom>
+        </p:spPr>
+      </p:pic>
     </p:spTree>
   </p:cSld>
   <p:clrMapOvr>
@@ -3801,21 +3589,289 @@
               </a:defRPr>
             </a:pPr>
             <a:r>
-              <a:t>Data &amp; approach</a:t>
-            </a:r>
-          </a:p>
-        </p:txBody>
-      </p:sp>
-      <p:sp>
-        <p:nvSpPr>
-          <p:cNvPr id="3" name="TextBox 2"/>
+              <a:t>Why customers leave — reasons, contract &amp; competition</a:t>
+            </a:r>
+          </a:p>
+        </p:txBody>
+      </p:sp>
+      <p:pic>
+        <p:nvPicPr>
+          <p:cNvPr id="3" name="Picture 2" descr="termination_reasons.png"/>
+          <p:cNvPicPr>
+            <a:picLocks noChangeAspect="1"/>
+          </p:cNvPicPr>
+          <p:nvPr/>
+        </p:nvPicPr>
+        <p:blipFill>
+          <a:blip r:embed="rId2"/>
+          <a:stretch>
+            <a:fillRect/>
+          </a:stretch>
+        </p:blipFill>
+        <p:spPr>
+          <a:xfrm>
+            <a:off x="274320" y="1005840"/>
+            <a:ext cx="6309360" cy="3364992"/>
+          </a:xfrm>
+          <a:prstGeom prst="rect">
+            <a:avLst/>
+          </a:prstGeom>
+        </p:spPr>
+      </p:pic>
+      <p:graphicFrame>
+        <p:nvGraphicFramePr>
+          <p:cNvPr id="4" name="Table 3"/>
+          <p:cNvGraphicFramePr>
+            <a:graphicFrameLocks noGrp="1"/>
+          </p:cNvGraphicFramePr>
+          <p:nvPr/>
+        </p:nvGraphicFramePr>
+        <p:xfrm>
+          <a:off x="6858000" y="1051560"/>
+          <a:ext cx="4754880" cy="1463040"/>
+        </p:xfrm>
+        <a:graphic>
+          <a:graphicData uri="http://schemas.openxmlformats.org/drawingml/2006/table">
+            <a:tbl>
+              <a:tblPr firstRow="1" bandRow="1">
+                <a:tableStyleId>{5C22544A-7EE6-4342-B048-85BDC9FD1C3A}</a:tableStyleId>
+              </a:tblPr>
+              <a:tblGrid>
+                <a:gridCol w="1584960"/>
+                <a:gridCol w="1584960"/>
+                <a:gridCol w="1584960"/>
+              </a:tblGrid>
+              <a:tr h="292608">
+                <a:tc>
+                  <a:txBody>
+                    <a:bodyPr/>
+                    <a:lstStyle/>
+                    <a:p>
+                      <a:r>
+                        <a:rPr sz="1100" b="1">
+                          <a:solidFill>
+                            <a:srgbClr val="1F4E79"/>
+                          </a:solidFill>
+                        </a:rPr>
+                        <a:t>Term</a:t>
+                      </a:r>
+                    </a:p>
+                  </a:txBody>
+                  <a:tcPr/>
+                </a:tc>
+                <a:tc>
+                  <a:txBody>
+                    <a:bodyPr/>
+                    <a:lstStyle/>
+                    <a:p>
+                      <a:r>
+                        <a:rPr sz="1100" b="1">
+                          <a:solidFill>
+                            <a:srgbClr val="1F4E79"/>
+                          </a:solidFill>
+                        </a:rPr>
+                        <a:t>OR</a:t>
+                      </a:r>
+                    </a:p>
+                  </a:txBody>
+                  <a:tcPr/>
+                </a:tc>
+                <a:tc>
+                  <a:txBody>
+                    <a:bodyPr/>
+                    <a:lstStyle/>
+                    <a:p>
+                      <a:r>
+                        <a:rPr sz="1100" b="1">
+                          <a:solidFill>
+                            <a:srgbClr val="1F4E79"/>
+                          </a:solidFill>
+                        </a:rPr>
+                        <a:t>sig.</a:t>
+                      </a:r>
+                    </a:p>
+                  </a:txBody>
+                  <a:tcPr/>
+                </a:tc>
+              </a:tr>
+              <a:tr h="292608">
+                <a:tc>
+                  <a:txBody>
+                    <a:bodyPr/>
+                    <a:lstStyle/>
+                    <a:p>
+                      <a:r>
+                        <a:rPr sz="1100"/>
+                        <a:t>24 Months (vs 12m)</a:t>
+                      </a:r>
+                    </a:p>
+                  </a:txBody>
+                  <a:tcPr/>
+                </a:tc>
+                <a:tc>
+                  <a:txBody>
+                    <a:bodyPr/>
+                    <a:lstStyle/>
+                    <a:p>
+                      <a:r>
+                        <a:rPr sz="1100"/>
+                        <a:t>0.22</a:t>
+                      </a:r>
+                    </a:p>
+                  </a:txBody>
+                  <a:tcPr/>
+                </a:tc>
+                <a:tc>
+                  <a:txBody>
+                    <a:bodyPr/>
+                    <a:lstStyle/>
+                    <a:p>
+                      <a:r>
+                        <a:rPr sz="1100"/>
+                        <a:t>***</a:t>
+                      </a:r>
+                    </a:p>
+                  </a:txBody>
+                  <a:tcPr/>
+                </a:tc>
+              </a:tr>
+              <a:tr h="292608">
+                <a:tc>
+                  <a:txBody>
+                    <a:bodyPr/>
+                    <a:lstStyle/>
+                    <a:p>
+                      <a:r>
+                        <a:rPr sz="1100"/>
+                        <a:t>Monthly (vs 12m)</a:t>
+                      </a:r>
+                    </a:p>
+                  </a:txBody>
+                  <a:tcPr/>
+                </a:tc>
+                <a:tc>
+                  <a:txBody>
+                    <a:bodyPr/>
+                    <a:lstStyle/>
+                    <a:p>
+                      <a:r>
+                        <a:rPr sz="1100"/>
+                        <a:t>1.28</a:t>
+                      </a:r>
+                    </a:p>
+                  </a:txBody>
+                  <a:tcPr/>
+                </a:tc>
+                <a:tc>
+                  <a:txBody>
+                    <a:bodyPr/>
+                    <a:lstStyle/>
+                    <a:p>
+                      <a:r>
+                        <a:rPr sz="1100"/>
+                        <a:t>***</a:t>
+                      </a:r>
+                    </a:p>
+                  </a:txBody>
+                  <a:tcPr/>
+                </a:tc>
+              </a:tr>
+              <a:tr h="292608">
+                <a:tc>
+                  <a:txBody>
+                    <a:bodyPr/>
+                    <a:lstStyle/>
+                    <a:p>
+                      <a:r>
+                        <a:rPr sz="1100"/>
+                        <a:t>1 competitor</a:t>
+                      </a:r>
+                    </a:p>
+                  </a:txBody>
+                  <a:tcPr/>
+                </a:tc>
+                <a:tc>
+                  <a:txBody>
+                    <a:bodyPr/>
+                    <a:lstStyle/>
+                    <a:p>
+                      <a:r>
+                        <a:rPr sz="1100"/>
+                        <a:t>0.90</a:t>
+                      </a:r>
+                    </a:p>
+                  </a:txBody>
+                  <a:tcPr/>
+                </a:tc>
+                <a:tc>
+                  <a:txBody>
+                    <a:bodyPr/>
+                    <a:lstStyle/>
+                    <a:p>
+                      <a:r>
+                        <a:rPr sz="1100"/>
+                        <a:t>n.s.</a:t>
+                      </a:r>
+                    </a:p>
+                  </a:txBody>
+                  <a:tcPr/>
+                </a:tc>
+              </a:tr>
+              <a:tr h="292608">
+                <a:tc>
+                  <a:txBody>
+                    <a:bodyPr/>
+                    <a:lstStyle/>
+                    <a:p>
+                      <a:r>
+                        <a:rPr sz="1100"/>
+                        <a:t>2 competitors</a:t>
+                      </a:r>
+                    </a:p>
+                  </a:txBody>
+                  <a:tcPr/>
+                </a:tc>
+                <a:tc>
+                  <a:txBody>
+                    <a:bodyPr/>
+                    <a:lstStyle/>
+                    <a:p>
+                      <a:r>
+                        <a:rPr sz="1100"/>
+                        <a:t>0.87</a:t>
+                      </a:r>
+                    </a:p>
+                  </a:txBody>
+                  <a:tcPr/>
+                </a:tc>
+                <a:tc>
+                  <a:txBody>
+                    <a:bodyPr/>
+                    <a:lstStyle/>
+                    <a:p>
+                      <a:r>
+                        <a:rPr sz="1100"/>
+                        <a:t>n.s.</a:t>
+                      </a:r>
+                    </a:p>
+                  </a:txBody>
+                  <a:tcPr/>
+                </a:tc>
+              </a:tr>
+            </a:tbl>
+          </a:graphicData>
+        </a:graphic>
+      </p:graphicFrame>
+      <p:sp>
+        <p:nvSpPr>
+          <p:cNvPr id="5" name="TextBox 4"/>
           <p:cNvSpPr txBox="1"/>
           <p:nvPr/>
         </p:nvSpPr>
         <p:spPr>
           <a:xfrm>
-            <a:off x="457200" y="1051560"/>
-            <a:ext cx="11247120" cy="5394960"/>
+            <a:off x="6858000" y="2743200"/>
+            <a:ext cx="4937760" cy="5394960"/>
           </a:xfrm>
           <a:prstGeom prst="rect">
             <a:avLst/>
@@ -3830,116 +3886,70 @@
           <a:p>
             <a:pPr>
               <a:spcAft>
-                <a:spcPts val="1000"/>
+                <a:spcPts val="900"/>
               </a:spcAft>
             </a:pPr>
             <a:r>
-              <a:rPr sz="1500" b="1">
+              <a:rPr sz="1200" b="1">
                 <a:solidFill>
                   <a:srgbClr val="1F4E79"/>
                 </a:solidFill>
               </a:rPr>
-              <a:t>•  Data</a:t>
-            </a:r>
-            <a:r>
-              <a:rPr sz="1500" b="0">
+              <a:t>•  Moving Home/Going Away = 82%</a:t>
+            </a:r>
+            <a:r>
+              <a:rPr sz="1200" b="0">
                 <a:solidFill>
                   <a:srgbClr val="222222"/>
                 </a:solidFill>
               </a:rPr>
-              <a:t>  —  10,000 customers · activations Jan 2020 – Dec 2024 · terminations recorded to Sep 2025. Fields: city, postcode, bundle, contract duration, competitors, activation/termination dates and reason.</a:t>
+              <a:t>  —  5,701 customers — structural churn, not dissatisfaction; 'Customer not leaving' (7.5%) is ambiguous but profile-matched to the base; Complaint + Package/Deal/Cost &lt; 2%.</a:t>
             </a:r>
           </a:p>
           <a:p>
             <a:pPr>
               <a:spcAft>
-                <a:spcPts val="1000"/>
+                <a:spcPts val="900"/>
               </a:spcAft>
             </a:pPr>
             <a:r>
-              <a:rPr sz="1500" b="1">
+              <a:rPr sz="1200" b="1">
                 <a:solidFill>
                   <a:srgbClr val="1F4E79"/>
                 </a:solidFill>
               </a:rPr>
-              <a:t>•  Cleaning</a:t>
-            </a:r>
-            <a:r>
-              <a:rPr sz="1500" b="0">
+              <a:t>•  Contract is the biggest lever</a:t>
+            </a:r>
+            <a:r>
+              <a:rPr sz="1200" b="0">
                 <a:solidFill>
                   <a:srgbClr val="222222"/>
                 </a:solidFill>
               </a:rPr>
-              <a:t>  —  Excel serial dates parsed, '-' placeholders → missing, no duplicates; only missing fields are termination-related — missing termination = still active, i.e. meaningful, not lost data.</a:t>
+              <a:t>  —  24-month = 78% lower churn odds vs 12-month; monthly rolling +28%. Part of the gap is mechanical (still in-contract).</a:t>
             </a:r>
           </a:p>
           <a:p>
             <a:pPr>
               <a:spcAft>
-                <a:spcPts val="1000"/>
+                <a:spcPts val="900"/>
               </a:spcAft>
             </a:pPr>
             <a:r>
-              <a:rPr sz="1500" b="1">
+              <a:rPr sz="1200" b="1">
                 <a:solidFill>
                   <a:srgbClr val="1F4E79"/>
                 </a:solidFill>
               </a:rPr>
-              <a:t>•  Churn definition</a:t>
-            </a:r>
-            <a:r>
-              <a:rPr sz="1500" b="0">
+              <a:t>•  Competitors don't move churn</a:t>
+            </a:r>
+            <a:r>
+              <a:rPr sz="1200" b="0">
                 <a:solidFill>
                   <a:srgbClr val="222222"/>
                 </a:solidFill>
               </a:rPr>
-              <a:t>  —  a record with a termination date counts as churned (6,947 churned / 3,053 active).</a:t>
-            </a:r>
-          </a:p>
-          <a:p>
-            <a:pPr>
-              <a:spcAft>
-                <a:spcPts val="1000"/>
-              </a:spcAft>
-            </a:pPr>
-            <a:r>
-              <a:rPr sz="1500" b="1">
-                <a:solidFill>
-                  <a:srgbClr val="1F4E79"/>
-                </a:solidFill>
-              </a:rPr>
-              <a:t>•  Analytics flow</a:t>
-            </a:r>
-            <a:r>
-              <a:rPr sz="1500" b="0">
-                <a:solidFill>
-                  <a:srgbClr val="222222"/>
-                </a:solidFill>
-              </a:rPr>
-              <a:t>  —  descriptive (where churn concentrates) → statistics (chi-square, Cramér's V, correlations) → predictive (logistic regression, odds ratios + holdout evaluation) → prescriptive (recommendations).</a:t>
-            </a:r>
-          </a:p>
-          <a:p>
-            <a:pPr>
-              <a:spcAft>
-                <a:spcPts val="1000"/>
-              </a:spcAft>
-            </a:pPr>
-            <a:r>
-              <a:rPr sz="1500" b="1">
-                <a:solidFill>
-                  <a:srgbClr val="1F4E79"/>
-                </a:solidFill>
-              </a:rPr>
-              <a:t>•  Model</a:t>
-            </a:r>
-            <a:r>
-              <a:rPr sz="1500" b="0">
-                <a:solidFill>
-                  <a:srgbClr val="222222"/>
-                </a:solidFill>
-              </a:rPr>
-              <a:t>  —  logistic regression on contract type, city, bundle group, competitors, activation year — chosen for interpretability: holdout accuracy 78%, AUC 0.80, recall 89%.</a:t>
+              <a:t>  —  1 or 2 rivals present: no significant effect (p = 0.13 / 0.72).</a:t>
             </a:r>
           </a:p>
         </p:txBody>
@@ -3992,14 +4002,14 @@
               </a:defRPr>
             </a:pPr>
             <a:r>
-              <a:t>Headline findings — where churn concentrates</a:t>
+              <a:t>Where, what &amp; when — geography, bundle, timing</a:t>
             </a:r>
           </a:p>
         </p:txBody>
       </p:sp>
       <p:pic>
         <p:nvPicPr>
-          <p:cNvPr id="3" name="Picture 2" descr="nb_contract_churn.png"/>
+          <p:cNvPr id="3" name="Picture 2" descr="nb_city_churn.png"/>
           <p:cNvPicPr>
             <a:picLocks noChangeAspect="1"/>
           </p:cNvPicPr>
@@ -4013,8 +4023,8 @@
         </p:blipFill>
         <p:spPr>
           <a:xfrm>
-            <a:off x="365760" y="914400"/>
-            <a:ext cx="5669280" cy="3505624"/>
+            <a:off x="274320" y="914400"/>
+            <a:ext cx="3931920" cy="2377440"/>
           </a:xfrm>
           <a:prstGeom prst="rect">
             <a:avLst/>
@@ -4023,7 +4033,7 @@
       </p:pic>
       <p:pic>
         <p:nvPicPr>
-          <p:cNvPr id="4" name="Picture 3" descr="nb_city_churn.png"/>
+          <p:cNvPr id="4" name="Picture 3" descr="nb_bundle_churn_all.png"/>
           <p:cNvPicPr>
             <a:picLocks noChangeAspect="1"/>
           </p:cNvPicPr>
@@ -4037,8 +4047,8 @@
         </p:blipFill>
         <p:spPr>
           <a:xfrm>
-            <a:off x="6217920" y="914400"/>
-            <a:ext cx="5669280" cy="3507845"/>
+            <a:off x="4297680" y="914400"/>
+            <a:ext cx="3931920" cy="2377440"/>
           </a:xfrm>
           <a:prstGeom prst="rect">
             <a:avLst/>
@@ -4047,7 +4057,7 @@
       </p:pic>
       <p:pic>
         <p:nvPicPr>
-          <p:cNvPr id="5" name="Picture 4" descr="nb_bundle_churn_all.png"/>
+          <p:cNvPr id="5" name="Picture 4" descr="nb_monthly_churn.png"/>
           <p:cNvPicPr>
             <a:picLocks noChangeAspect="1"/>
           </p:cNvPicPr>
@@ -4061,38 +4071,106 @@
         </p:blipFill>
         <p:spPr>
           <a:xfrm>
-            <a:off x="365760" y="3886200"/>
-            <a:ext cx="5669280" cy="3505624"/>
+            <a:off x="8321040" y="914400"/>
+            <a:ext cx="3749039" cy="2377440"/>
           </a:xfrm>
           <a:prstGeom prst="rect">
             <a:avLst/>
           </a:prstGeom>
         </p:spPr>
       </p:pic>
-      <p:pic>
-        <p:nvPicPr>
-          <p:cNvPr id="6" name="Picture 5" descr="nb_cohort_churn.png"/>
-          <p:cNvPicPr>
-            <a:picLocks noChangeAspect="1"/>
-          </p:cNvPicPr>
+      <p:sp>
+        <p:nvSpPr>
+          <p:cNvPr id="6" name="TextBox 5"/>
+          <p:cNvSpPr txBox="1"/>
           <p:nvPr/>
-        </p:nvPicPr>
-        <p:blipFill>
-          <a:blip r:embed="rId5"/>
-          <a:stretch>
-            <a:fillRect/>
-          </a:stretch>
-        </p:blipFill>
+        </p:nvSpPr>
         <p:spPr>
           <a:xfrm>
-            <a:off x="6217920" y="3886200"/>
-            <a:ext cx="5669280" cy="3505624"/>
+            <a:off x="457200" y="3840480"/>
+            <a:ext cx="11247120" cy="5394960"/>
           </a:xfrm>
           <a:prstGeom prst="rect">
             <a:avLst/>
           </a:prstGeom>
+          <a:noFill/>
         </p:spPr>
-      </p:pic>
+        <p:txBody>
+          <a:bodyPr wrap="square">
+            <a:spAutoFit/>
+          </a:bodyPr>
+          <a:lstStyle/>
+          <a:p>
+            <a:pPr>
+              <a:spcAft>
+                <a:spcPts val="900"/>
+              </a:spcAft>
+            </a:pPr>
+            <a:r>
+              <a:rPr sz="1300" b="1">
+                <a:solidFill>
+                  <a:srgbClr val="1F4E79"/>
+                </a:solidFill>
+              </a:rPr>
+              <a:t>•  Where</a:t>
+            </a:r>
+            <a:r>
+              <a:rPr sz="1300" b="0">
+                <a:solidFill>
+                  <a:srgbClr val="222222"/>
+                </a:solidFill>
+              </a:rPr>
+              <a:t>  —  Manchester churns ~51% more than Leeds after controls (OR 1.51); Nottingham ~64% less (OR 0.36). Leeds 82% / Manchester 77% vs London 63% / Nottingham 41%.</a:t>
+            </a:r>
+          </a:p>
+          <a:p>
+            <a:pPr>
+              <a:spcAft>
+                <a:spcPts val="900"/>
+              </a:spcAft>
+            </a:pPr>
+            <a:r>
+              <a:rPr sz="1300" b="1">
+                <a:solidFill>
+                  <a:srgbClr val="1F4E79"/>
+                </a:solidFill>
+              </a:rPr>
+              <a:t>•  What</a:t>
+            </a:r>
+            <a:r>
+              <a:rPr sz="1300" b="0">
+                <a:solidFill>
+                  <a:srgbClr val="222222"/>
+                </a:solidFill>
+              </a:rPr>
+              <a:t>  —  50Mb entry tier churns most — 82% (n=1,030; OR 1.39 vs 150Mb). Mid/high tiers lower: 500Mb 67%, 1Gb 66%.</a:t>
+            </a:r>
+          </a:p>
+          <a:p>
+            <a:pPr>
+              <a:spcAft>
+                <a:spcPts val="900"/>
+              </a:spcAft>
+            </a:pPr>
+            <a:r>
+              <a:rPr sz="1300" b="1">
+                <a:solidFill>
+                  <a:srgbClr val="1F4E79"/>
+                </a:solidFill>
+              </a:rPr>
+              <a:t>•  When</a:t>
+            </a:r>
+            <a:r>
+              <a:rPr sz="1300" b="0">
+                <a:solidFill>
+                  <a:srgbClr val="222222"/>
+                </a:solidFill>
+              </a:rPr>
+              <a:t>  —  churn concentrates around contract end — median churned tenure ≈ 12 months. &lt;6-month bands show 100% (observation artifact) but ~1,070 real early churners warrant onboarding review; 28 same-day terminations; 2024's 37% cohort rate is mostly less time to churn — report on a survival basis.</a:t>
+            </a:r>
+          </a:p>
+        </p:txBody>
+      </p:sp>
     </p:spTree>
   </p:cSld>
   <p:clrMapOvr>
@@ -4141,1214 +4219,20 @@
               </a:defRPr>
             </a:pPr>
             <a:r>
-              <a:t>Why customers leave — termination reasons</a:t>
-            </a:r>
-          </a:p>
-        </p:txBody>
-      </p:sp>
-      <p:pic>
-        <p:nvPicPr>
-          <p:cNvPr id="3" name="Picture 2" descr="termination_reasons.png"/>
-          <p:cNvPicPr>
-            <a:picLocks noChangeAspect="1"/>
-          </p:cNvPicPr>
+              <a:t>UK fibre market context &amp; recommendations</a:t>
+            </a:r>
+          </a:p>
+        </p:txBody>
+      </p:sp>
+      <p:sp>
+        <p:nvSpPr>
+          <p:cNvPr id="3" name="TextBox 2"/>
+          <p:cNvSpPr txBox="1"/>
           <p:nvPr/>
-        </p:nvPicPr>
-        <p:blipFill>
-          <a:blip r:embed="rId2"/>
-          <a:stretch>
-            <a:fillRect/>
-          </a:stretch>
-        </p:blipFill>
+        </p:nvSpPr>
         <p:spPr>
           <a:xfrm>
-            <a:off x="365760" y="1005840"/>
-            <a:ext cx="6949440" cy="3706368"/>
-          </a:xfrm>
-          <a:prstGeom prst="rect">
-            <a:avLst/>
-          </a:prstGeom>
-        </p:spPr>
-      </p:pic>
-      <p:sp>
-        <p:nvSpPr>
-          <p:cNvPr id="4" name="TextBox 3"/>
-          <p:cNvSpPr txBox="1"/>
-          <p:nvPr/>
-        </p:nvSpPr>
-        <p:spPr>
-          <a:xfrm>
-            <a:off x="7498079" y="1097280"/>
-            <a:ext cx="4297680" cy="5394960"/>
-          </a:xfrm>
-          <a:prstGeom prst="rect">
-            <a:avLst/>
-          </a:prstGeom>
-          <a:noFill/>
-        </p:spPr>
-        <p:txBody>
-          <a:bodyPr wrap="square">
-            <a:spAutoFit/>
-          </a:bodyPr>
-          <a:lstStyle/>
-          <a:p>
-            <a:pPr>
-              <a:spcAft>
-                <a:spcPts val="1000"/>
-              </a:spcAft>
-            </a:pPr>
-            <a:r>
-              <a:rPr sz="1300" b="1">
-                <a:solidFill>
-                  <a:srgbClr val="1F4E79"/>
-                </a:solidFill>
-              </a:rPr>
-              <a:t>•  Moving Home/Going Away</a:t>
-            </a:r>
-            <a:r>
-              <a:rPr sz="1300" b="0">
-                <a:solidFill>
-                  <a:srgbClr val="222222"/>
-                </a:solidFill>
-              </a:rPr>
-              <a:t>  —  82.1% of all terminations (5,701 customers) — largely structural: the customer relocates, not necessarily dissatisfied.</a:t>
-            </a:r>
-          </a:p>
-          <a:p>
-            <a:pPr>
-              <a:spcAft>
-                <a:spcPts val="1000"/>
-              </a:spcAft>
-            </a:pPr>
-            <a:r>
-              <a:rPr sz="1300" b="1">
-                <a:solidFill>
-                  <a:srgbClr val="1F4E79"/>
-                </a:solidFill>
-              </a:rPr>
-              <a:t>•  'Customer not leaving'</a:t>
-            </a:r>
-            <a:r>
-              <a:rPr sz="1300" b="0">
-                <a:solidFill>
-                  <a:srgbClr val="222222"/>
-                </a:solidFill>
-              </a:rPr>
-              <a:t>  —  7.5% of churn records (521) — ambiguous category; its profile matches the overall base, kept but flagged.</a:t>
-            </a:r>
-          </a:p>
-          <a:p>
-            <a:pPr>
-              <a:spcAft>
-                <a:spcPts val="1000"/>
-              </a:spcAft>
-            </a:pPr>
-            <a:r>
-              <a:rPr sz="1300" b="1">
-                <a:solidFill>
-                  <a:srgbClr val="1F4E79"/>
-                </a:solidFill>
-              </a:rPr>
-              <a:t>•  Bad Debt</a:t>
-            </a:r>
-            <a:r>
-              <a:rPr sz="1300" b="0">
-                <a:solidFill>
-                  <a:srgbClr val="222222"/>
-                </a:solidFill>
-              </a:rPr>
-              <a:t>  —  5.5% — a collections/pricing-design issue more than a service issue.</a:t>
-            </a:r>
-          </a:p>
-          <a:p>
-            <a:pPr>
-              <a:spcAft>
-                <a:spcPts val="1000"/>
-              </a:spcAft>
-            </a:pPr>
-            <a:r>
-              <a:rPr sz="1300" b="1">
-                <a:solidFill>
-                  <a:srgbClr val="1F4E79"/>
-                </a:solidFill>
-              </a:rPr>
-              <a:t>•  Complaint + Package/Deal/Cost</a:t>
-            </a:r>
-            <a:r>
-              <a:rPr sz="1300" b="0">
-                <a:solidFill>
-                  <a:srgbClr val="222222"/>
-                </a:solidFill>
-              </a:rPr>
-              <a:t>  —  under 2% combined — classic service/price churn is a small share.</a:t>
-            </a:r>
-          </a:p>
-        </p:txBody>
-      </p:sp>
-    </p:spTree>
-  </p:cSld>
-  <p:clrMapOvr>
-    <a:masterClrMapping/>
-  </p:clrMapOvr>
-</p:sld>
-</file>
-
-<file path=ppt/slides/slide6.xml><?xml version="1.0" encoding="utf-8"?>
-<p:sld xmlns:a="http://schemas.openxmlformats.org/drawingml/2006/main" xmlns:p="http://schemas.openxmlformats.org/presentationml/2006/main" xmlns:r="http://schemas.openxmlformats.org/officeDocument/2006/relationships">
-  <p:cSld>
-    <p:spTree>
-      <p:nvGrpSpPr>
-        <p:cNvPr id="1" name=""/>
-        <p:cNvGrpSpPr/>
-        <p:nvPr/>
-      </p:nvGrpSpPr>
-      <p:grpSpPr/>
-      <p:sp>
-        <p:nvSpPr>
-          <p:cNvPr id="2" name="TextBox 1"/>
-          <p:cNvSpPr txBox="1"/>
-          <p:nvPr/>
-        </p:nvSpPr>
-        <p:spPr>
-          <a:xfrm>
-            <a:off x="457200" y="228600"/>
-            <a:ext cx="11247120" cy="640080"/>
-          </a:xfrm>
-          <a:prstGeom prst="rect">
-            <a:avLst/>
-          </a:prstGeom>
-          <a:noFill/>
-        </p:spPr>
-        <p:txBody>
-          <a:bodyPr wrap="none">
-            <a:spAutoFit/>
-          </a:bodyPr>
-          <a:lstStyle/>
-          <a:p>
-            <a:pPr>
-              <a:defRPr sz="2800" b="1">
-                <a:solidFill>
-                  <a:srgbClr val="1F4E79"/>
-                </a:solidFill>
-              </a:defRPr>
-            </a:pPr>
-            <a:r>
-              <a:t>Contract length &amp; competition</a:t>
-            </a:r>
-          </a:p>
-        </p:txBody>
-      </p:sp>
-      <p:pic>
-        <p:nvPicPr>
-          <p:cNvPr id="3" name="Picture 2" descr="nb_contract_churn.png"/>
-          <p:cNvPicPr>
-            <a:picLocks noChangeAspect="1"/>
-          </p:cNvPicPr>
-          <p:nvPr/>
-        </p:nvPicPr>
-        <p:blipFill>
-          <a:blip r:embed="rId2"/>
-          <a:stretch>
-            <a:fillRect/>
-          </a:stretch>
-        </p:blipFill>
-        <p:spPr>
-          <a:xfrm>
-            <a:off x="365760" y="1005840"/>
-            <a:ext cx="5852160" cy="3618709"/>
-          </a:xfrm>
-          <a:prstGeom prst="rect">
-            <a:avLst/>
-          </a:prstGeom>
-        </p:spPr>
-      </p:pic>
-      <p:graphicFrame>
-        <p:nvGraphicFramePr>
-          <p:cNvPr id="4" name="Table 3"/>
-          <p:cNvGraphicFramePr>
-            <a:graphicFrameLocks noGrp="1"/>
-          </p:cNvGraphicFramePr>
-          <p:nvPr/>
-        </p:nvGraphicFramePr>
-        <p:xfrm>
-          <a:off x="6583680" y="1188720"/>
-          <a:ext cx="5120640" cy="1554480"/>
-        </p:xfrm>
-        <a:graphic>
-          <a:graphicData uri="http://schemas.openxmlformats.org/drawingml/2006/table">
-            <a:tbl>
-              <a:tblPr firstRow="1" bandRow="1">
-                <a:tableStyleId>{5C22544A-7EE6-4342-B048-85BDC9FD1C3A}</a:tableStyleId>
-              </a:tblPr>
-              <a:tblGrid>
-                <a:gridCol w="1706880"/>
-                <a:gridCol w="1706880"/>
-                <a:gridCol w="1706880"/>
-              </a:tblGrid>
-              <a:tr h="310896">
-                <a:tc>
-                  <a:txBody>
-                    <a:bodyPr/>
-                    <a:lstStyle/>
-                    <a:p>
-                      <a:r>
-                        <a:rPr sz="1200" b="1">
-                          <a:solidFill>
-                            <a:srgbClr val="1F4E79"/>
-                          </a:solidFill>
-                        </a:rPr>
-                        <a:t>Term</a:t>
-                      </a:r>
-                    </a:p>
-                  </a:txBody>
-                  <a:tcPr/>
-                </a:tc>
-                <a:tc>
-                  <a:txBody>
-                    <a:bodyPr/>
-                    <a:lstStyle/>
-                    <a:p>
-                      <a:r>
-                        <a:rPr sz="1200" b="1">
-                          <a:solidFill>
-                            <a:srgbClr val="1F4E79"/>
-                          </a:solidFill>
-                        </a:rPr>
-                        <a:t>OR</a:t>
-                      </a:r>
-                    </a:p>
-                  </a:txBody>
-                  <a:tcPr/>
-                </a:tc>
-                <a:tc>
-                  <a:txBody>
-                    <a:bodyPr/>
-                    <a:lstStyle/>
-                    <a:p>
-                      <a:r>
-                        <a:rPr sz="1200" b="1">
-                          <a:solidFill>
-                            <a:srgbClr val="1F4E79"/>
-                          </a:solidFill>
-                        </a:rPr>
-                        <a:t>sig.</a:t>
-                      </a:r>
-                    </a:p>
-                  </a:txBody>
-                  <a:tcPr/>
-                </a:tc>
-              </a:tr>
-              <a:tr h="310896">
-                <a:tc>
-                  <a:txBody>
-                    <a:bodyPr/>
-                    <a:lstStyle/>
-                    <a:p>
-                      <a:r>
-                        <a:rPr sz="1200"/>
-                        <a:t>24 Months (vs 12m)</a:t>
-                      </a:r>
-                    </a:p>
-                  </a:txBody>
-                  <a:tcPr/>
-                </a:tc>
-                <a:tc>
-                  <a:txBody>
-                    <a:bodyPr/>
-                    <a:lstStyle/>
-                    <a:p>
-                      <a:r>
-                        <a:rPr sz="1200"/>
-                        <a:t>0.22</a:t>
-                      </a:r>
-                    </a:p>
-                  </a:txBody>
-                  <a:tcPr/>
-                </a:tc>
-                <a:tc>
-                  <a:txBody>
-                    <a:bodyPr/>
-                    <a:lstStyle/>
-                    <a:p>
-                      <a:r>
-                        <a:rPr sz="1200"/>
-                        <a:t>***</a:t>
-                      </a:r>
-                    </a:p>
-                  </a:txBody>
-                  <a:tcPr/>
-                </a:tc>
-              </a:tr>
-              <a:tr h="310896">
-                <a:tc>
-                  <a:txBody>
-                    <a:bodyPr/>
-                    <a:lstStyle/>
-                    <a:p>
-                      <a:r>
-                        <a:rPr sz="1200"/>
-                        <a:t>Monthly (vs 12m)</a:t>
-                      </a:r>
-                    </a:p>
-                  </a:txBody>
-                  <a:tcPr/>
-                </a:tc>
-                <a:tc>
-                  <a:txBody>
-                    <a:bodyPr/>
-                    <a:lstStyle/>
-                    <a:p>
-                      <a:r>
-                        <a:rPr sz="1200"/>
-                        <a:t>1.28</a:t>
-                      </a:r>
-                    </a:p>
-                  </a:txBody>
-                  <a:tcPr/>
-                </a:tc>
-                <a:tc>
-                  <a:txBody>
-                    <a:bodyPr/>
-                    <a:lstStyle/>
-                    <a:p>
-                      <a:r>
-                        <a:rPr sz="1200"/>
-                        <a:t>***</a:t>
-                      </a:r>
-                    </a:p>
-                  </a:txBody>
-                  <a:tcPr/>
-                </a:tc>
-              </a:tr>
-              <a:tr h="310896">
-                <a:tc>
-                  <a:txBody>
-                    <a:bodyPr/>
-                    <a:lstStyle/>
-                    <a:p>
-                      <a:r>
-                        <a:rPr sz="1200"/>
-                        <a:t>1 competitor</a:t>
-                      </a:r>
-                    </a:p>
-                  </a:txBody>
-                  <a:tcPr/>
-                </a:tc>
-                <a:tc>
-                  <a:txBody>
-                    <a:bodyPr/>
-                    <a:lstStyle/>
-                    <a:p>
-                      <a:r>
-                        <a:rPr sz="1200"/>
-                        <a:t>0.90</a:t>
-                      </a:r>
-                    </a:p>
-                  </a:txBody>
-                  <a:tcPr/>
-                </a:tc>
-                <a:tc>
-                  <a:txBody>
-                    <a:bodyPr/>
-                    <a:lstStyle/>
-                    <a:p>
-                      <a:r>
-                        <a:rPr sz="1200"/>
-                        <a:t>n.s.</a:t>
-                      </a:r>
-                    </a:p>
-                  </a:txBody>
-                  <a:tcPr/>
-                </a:tc>
-              </a:tr>
-              <a:tr h="310896">
-                <a:tc>
-                  <a:txBody>
-                    <a:bodyPr/>
-                    <a:lstStyle/>
-                    <a:p>
-                      <a:r>
-                        <a:rPr sz="1200"/>
-                        <a:t>2 competitors</a:t>
-                      </a:r>
-                    </a:p>
-                  </a:txBody>
-                  <a:tcPr/>
-                </a:tc>
-                <a:tc>
-                  <a:txBody>
-                    <a:bodyPr/>
-                    <a:lstStyle/>
-                    <a:p>
-                      <a:r>
-                        <a:rPr sz="1200"/>
-                        <a:t>0.87</a:t>
-                      </a:r>
-                    </a:p>
-                  </a:txBody>
-                  <a:tcPr/>
-                </a:tc>
-                <a:tc>
-                  <a:txBody>
-                    <a:bodyPr/>
-                    <a:lstStyle/>
-                    <a:p>
-                      <a:r>
-                        <a:rPr sz="1200"/>
-                        <a:t>n.s.</a:t>
-                      </a:r>
-                    </a:p>
-                  </a:txBody>
-                  <a:tcPr/>
-                </a:tc>
-              </a:tr>
-            </a:tbl>
-          </a:graphicData>
-        </a:graphic>
-      </p:graphicFrame>
-      <p:sp>
-        <p:nvSpPr>
-          <p:cNvPr id="5" name="TextBox 4"/>
-          <p:cNvSpPr txBox="1"/>
-          <p:nvPr/>
-        </p:nvSpPr>
-        <p:spPr>
-          <a:xfrm>
-            <a:off x="6583680" y="2926080"/>
-            <a:ext cx="5120640" cy="5394960"/>
-          </a:xfrm>
-          <a:prstGeom prst="rect">
-            <a:avLst/>
-          </a:prstGeom>
-          <a:noFill/>
-        </p:spPr>
-        <p:txBody>
-          <a:bodyPr wrap="square">
-            <a:spAutoFit/>
-          </a:bodyPr>
-          <a:lstStyle/>
-          <a:p>
-            <a:pPr>
-              <a:spcAft>
-                <a:spcPts val="1000"/>
-              </a:spcAft>
-            </a:pPr>
-            <a:r>
-              <a:rPr sz="1200" b="1">
-                <a:solidFill>
-                  <a:srgbClr val="1F4E79"/>
-                </a:solidFill>
-              </a:rPr>
-              <a:t>•  Contract is the biggest controllable lever</a:t>
-            </a:r>
-            <a:r>
-              <a:rPr sz="1200" b="0">
-                <a:solidFill>
-                  <a:srgbClr val="222222"/>
-                </a:solidFill>
-              </a:rPr>
-              <a:t>  —  24-month customers have ~78% lower odds of churning than 12-month; monthly-rolling churns more (+28%).</a:t>
-            </a:r>
-          </a:p>
-          <a:p>
-            <a:pPr>
-              <a:spcAft>
-                <a:spcPts val="1000"/>
-              </a:spcAft>
-            </a:pPr>
-            <a:r>
-              <a:rPr sz="1200" b="1">
-                <a:solidFill>
-                  <a:srgbClr val="1F4E79"/>
-                </a:solidFill>
-              </a:rPr>
-              <a:t>•  Competition is not significant</a:t>
-            </a:r>
-            <a:r>
-              <a:rPr sz="1200" b="0">
-                <a:solidFill>
-                  <a:srgbClr val="222222"/>
-                </a:solidFill>
-              </a:rPr>
-              <a:t>  —  having 1 or 2 competitors in the area does not move churn odds (p = 0.13 / 0.72) — presence of rivals alone doesn't drive exits.</a:t>
-            </a:r>
-          </a:p>
-          <a:p>
-            <a:pPr>
-              <a:spcAft>
-                <a:spcPts val="1000"/>
-              </a:spcAft>
-            </a:pPr>
-            <a:r>
-              <a:rPr sz="1200" b="1">
-                <a:solidFill>
-                  <a:srgbClr val="1F4E79"/>
-                </a:solidFill>
-              </a:rPr>
-              <a:t>•  But</a:t>
-            </a:r>
-            <a:r>
-              <a:rPr sz="1200" b="0">
-                <a:solidFill>
-                  <a:srgbClr val="222222"/>
-                </a:solidFill>
-              </a:rPr>
-              <a:t>  —  part of the 24-month gap is mechanical (still in-contract) — it's a lever, not pure satisfaction.</a:t>
-            </a:r>
-          </a:p>
-        </p:txBody>
-      </p:sp>
-    </p:spTree>
-  </p:cSld>
-  <p:clrMapOvr>
-    <a:masterClrMapping/>
-  </p:clrMapOvr>
-</p:sld>
-</file>
-
-<file path=ppt/slides/slide7.xml><?xml version="1.0" encoding="utf-8"?>
-<p:sld xmlns:a="http://schemas.openxmlformats.org/drawingml/2006/main" xmlns:p="http://schemas.openxmlformats.org/presentationml/2006/main" xmlns:r="http://schemas.openxmlformats.org/officeDocument/2006/relationships">
-  <p:cSld>
-    <p:spTree>
-      <p:nvGrpSpPr>
-        <p:cNvPr id="1" name=""/>
-        <p:cNvGrpSpPr/>
-        <p:nvPr/>
-      </p:nvGrpSpPr>
-      <p:grpSpPr/>
-      <p:sp>
-        <p:nvSpPr>
-          <p:cNvPr id="2" name="TextBox 1"/>
-          <p:cNvSpPr txBox="1"/>
-          <p:nvPr/>
-        </p:nvSpPr>
-        <p:spPr>
-          <a:xfrm>
-            <a:off x="457200" y="228600"/>
-            <a:ext cx="11247120" cy="640080"/>
-          </a:xfrm>
-          <a:prstGeom prst="rect">
-            <a:avLst/>
-          </a:prstGeom>
-          <a:noFill/>
-        </p:spPr>
-        <p:txBody>
-          <a:bodyPr wrap="none">
-            <a:spAutoFit/>
-          </a:bodyPr>
-          <a:lstStyle/>
-          <a:p>
-            <a:pPr>
-              <a:defRPr sz="2800" b="1">
-                <a:solidFill>
-                  <a:srgbClr val="1F4E79"/>
-                </a:solidFill>
-              </a:defRPr>
-            </a:pPr>
-            <a:r>
-              <a:t>Where — geography</a:t>
-            </a:r>
-          </a:p>
-        </p:txBody>
-      </p:sp>
-      <p:pic>
-        <p:nvPicPr>
-          <p:cNvPr id="3" name="Picture 2" descr="nb_city_churn.png"/>
-          <p:cNvPicPr>
-            <a:picLocks noChangeAspect="1"/>
-          </p:cNvPicPr>
-          <p:nvPr/>
-        </p:nvPicPr>
-        <p:blipFill>
-          <a:blip r:embed="rId2"/>
-          <a:stretch>
-            <a:fillRect/>
-          </a:stretch>
-        </p:blipFill>
-        <p:spPr>
-          <a:xfrm>
-            <a:off x="365760" y="1005840"/>
-            <a:ext cx="6035040" cy="3734157"/>
-          </a:xfrm>
-          <a:prstGeom prst="rect">
-            <a:avLst/>
-          </a:prstGeom>
-        </p:spPr>
-      </p:pic>
-      <p:graphicFrame>
-        <p:nvGraphicFramePr>
-          <p:cNvPr id="4" name="Table 3"/>
-          <p:cNvGraphicFramePr>
-            <a:graphicFrameLocks noGrp="1"/>
-          </p:cNvGraphicFramePr>
-          <p:nvPr/>
-        </p:nvGraphicFramePr>
-        <p:xfrm>
-          <a:off x="6766560" y="1188720"/>
-          <a:ext cx="4937760" cy="1371600"/>
-        </p:xfrm>
-        <a:graphic>
-          <a:graphicData uri="http://schemas.openxmlformats.org/drawingml/2006/table">
-            <a:tbl>
-              <a:tblPr firstRow="1" bandRow="1">
-                <a:tableStyleId>{5C22544A-7EE6-4342-B048-85BDC9FD1C3A}</a:tableStyleId>
-              </a:tblPr>
-              <a:tblGrid>
-                <a:gridCol w="1645920"/>
-                <a:gridCol w="1645920"/>
-                <a:gridCol w="1645920"/>
-              </a:tblGrid>
-              <a:tr h="342900">
-                <a:tc>
-                  <a:txBody>
-                    <a:bodyPr/>
-                    <a:lstStyle/>
-                    <a:p>
-                      <a:r>
-                        <a:rPr sz="1200" b="1">
-                          <a:solidFill>
-                            <a:srgbClr val="1F4E79"/>
-                          </a:solidFill>
-                        </a:rPr>
-                        <a:t>City (vs Leeds)</a:t>
-                      </a:r>
-                    </a:p>
-                  </a:txBody>
-                  <a:tcPr/>
-                </a:tc>
-                <a:tc>
-                  <a:txBody>
-                    <a:bodyPr/>
-                    <a:lstStyle/>
-                    <a:p>
-                      <a:r>
-                        <a:rPr sz="1200" b="1">
-                          <a:solidFill>
-                            <a:srgbClr val="1F4E79"/>
-                          </a:solidFill>
-                        </a:rPr>
-                        <a:t>OR</a:t>
-                      </a:r>
-                    </a:p>
-                  </a:txBody>
-                  <a:tcPr/>
-                </a:tc>
-                <a:tc>
-                  <a:txBody>
-                    <a:bodyPr/>
-                    <a:lstStyle/>
-                    <a:p>
-                      <a:r>
-                        <a:rPr sz="1200" b="1">
-                          <a:solidFill>
-                            <a:srgbClr val="1F4E79"/>
-                          </a:solidFill>
-                        </a:rPr>
-                        <a:t>sig.</a:t>
-                      </a:r>
-                    </a:p>
-                  </a:txBody>
-                  <a:tcPr/>
-                </a:tc>
-              </a:tr>
-              <a:tr h="342900">
-                <a:tc>
-                  <a:txBody>
-                    <a:bodyPr/>
-                    <a:lstStyle/>
-                    <a:p>
-                      <a:r>
-                        <a:rPr sz="1200"/>
-                        <a:t>London</a:t>
-                      </a:r>
-                    </a:p>
-                  </a:txBody>
-                  <a:tcPr/>
-                </a:tc>
-                <a:tc>
-                  <a:txBody>
-                    <a:bodyPr/>
-                    <a:lstStyle/>
-                    <a:p>
-                      <a:r>
-                        <a:rPr sz="1200"/>
-                        <a:t>0.82</a:t>
-                      </a:r>
-                    </a:p>
-                  </a:txBody>
-                  <a:tcPr/>
-                </a:tc>
-                <a:tc>
-                  <a:txBody>
-                    <a:bodyPr/>
-                    <a:lstStyle/>
-                    <a:p>
-                      <a:r>
-                        <a:rPr sz="1200"/>
-                        <a:t>p=.08</a:t>
-                      </a:r>
-                    </a:p>
-                  </a:txBody>
-                  <a:tcPr/>
-                </a:tc>
-              </a:tr>
-              <a:tr h="342900">
-                <a:tc>
-                  <a:txBody>
-                    <a:bodyPr/>
-                    <a:lstStyle/>
-                    <a:p>
-                      <a:r>
-                        <a:rPr sz="1200"/>
-                        <a:t>Manchester</a:t>
-                      </a:r>
-                    </a:p>
-                  </a:txBody>
-                  <a:tcPr/>
-                </a:tc>
-                <a:tc>
-                  <a:txBody>
-                    <a:bodyPr/>
-                    <a:lstStyle/>
-                    <a:p>
-                      <a:r>
-                        <a:rPr sz="1200"/>
-                        <a:t>1.51</a:t>
-                      </a:r>
-                    </a:p>
-                  </a:txBody>
-                  <a:tcPr/>
-                </a:tc>
-                <a:tc>
-                  <a:txBody>
-                    <a:bodyPr/>
-                    <a:lstStyle/>
-                    <a:p>
-                      <a:r>
-                        <a:rPr sz="1200"/>
-                        <a:t>***</a:t>
-                      </a:r>
-                    </a:p>
-                  </a:txBody>
-                  <a:tcPr/>
-                </a:tc>
-              </a:tr>
-              <a:tr h="342900">
-                <a:tc>
-                  <a:txBody>
-                    <a:bodyPr/>
-                    <a:lstStyle/>
-                    <a:p>
-                      <a:r>
-                        <a:rPr sz="1200"/>
-                        <a:t>Nottingham</a:t>
-                      </a:r>
-                    </a:p>
-                  </a:txBody>
-                  <a:tcPr/>
-                </a:tc>
-                <a:tc>
-                  <a:txBody>
-                    <a:bodyPr/>
-                    <a:lstStyle/>
-                    <a:p>
-                      <a:r>
-                        <a:rPr sz="1200"/>
-                        <a:t>0.36</a:t>
-                      </a:r>
-                    </a:p>
-                  </a:txBody>
-                  <a:tcPr/>
-                </a:tc>
-                <a:tc>
-                  <a:txBody>
-                    <a:bodyPr/>
-                    <a:lstStyle/>
-                    <a:p>
-                      <a:r>
-                        <a:rPr sz="1200"/>
-                        <a:t>***</a:t>
-                      </a:r>
-                    </a:p>
-                  </a:txBody>
-                  <a:tcPr/>
-                </a:tc>
-              </a:tr>
-            </a:tbl>
-          </a:graphicData>
-        </a:graphic>
-      </p:graphicFrame>
-      <p:sp>
-        <p:nvSpPr>
-          <p:cNvPr id="5" name="TextBox 4"/>
-          <p:cNvSpPr txBox="1"/>
-          <p:nvPr/>
-        </p:nvSpPr>
-        <p:spPr>
-          <a:xfrm>
-            <a:off x="6766560" y="2834640"/>
-            <a:ext cx="4937760" cy="5394960"/>
-          </a:xfrm>
-          <a:prstGeom prst="rect">
-            <a:avLst/>
-          </a:prstGeom>
-          <a:noFill/>
-        </p:spPr>
-        <p:txBody>
-          <a:bodyPr wrap="square">
-            <a:spAutoFit/>
-          </a:bodyPr>
-          <a:lstStyle/>
-          <a:p>
-            <a:pPr>
-              <a:spcAft>
-                <a:spcPts val="1000"/>
-              </a:spcAft>
-            </a:pPr>
-            <a:r>
-              <a:rPr sz="1200" b="1">
-                <a:solidFill>
-                  <a:srgbClr val="1F4E79"/>
-                </a:solidFill>
-              </a:rPr>
-              <a:t>•  Manchester</a:t>
-            </a:r>
-            <a:r>
-              <a:rPr sz="1200" b="0">
-                <a:solidFill>
-                  <a:srgbClr val="222222"/>
-                </a:solidFill>
-              </a:rPr>
-              <a:t>  —  churns ~51% more than Leeds after controls — the strongest geography signal.</a:t>
-            </a:r>
-          </a:p>
-          <a:p>
-            <a:pPr>
-              <a:spcAft>
-                <a:spcPts val="1000"/>
-              </a:spcAft>
-            </a:pPr>
-            <a:r>
-              <a:rPr sz="1200" b="1">
-                <a:solidFill>
-                  <a:srgbClr val="1F4E79"/>
-                </a:solidFill>
-              </a:rPr>
-              <a:t>•  Nottingham</a:t>
-            </a:r>
-            <a:r>
-              <a:rPr sz="1200" b="0">
-                <a:solidFill>
-                  <a:srgbClr val="222222"/>
-                </a:solidFill>
-              </a:rPr>
-              <a:t>  —  churns ~64% less — smallest base (n=152) but consistent.</a:t>
-            </a:r>
-          </a:p>
-          <a:p>
-            <a:pPr>
-              <a:spcAft>
-                <a:spcPts val="1000"/>
-              </a:spcAft>
-            </a:pPr>
-            <a:r>
-              <a:rPr sz="1200" b="1">
-                <a:solidFill>
-                  <a:srgbClr val="1F4E79"/>
-                </a:solidFill>
-              </a:rPr>
-              <a:t>•  Action</a:t>
-            </a:r>
-            <a:r>
-              <a:rPr sz="1200" b="0">
-                <a:solidFill>
-                  <a:srgbClr val="222222"/>
-                </a:solidFill>
-              </a:rPr>
-              <a:t>  —  review service quality, install experience and altnet overbuild pressure in Manchester and Leeds.</a:t>
-            </a:r>
-          </a:p>
-        </p:txBody>
-      </p:sp>
-    </p:spTree>
-  </p:cSld>
-  <p:clrMapOvr>
-    <a:masterClrMapping/>
-  </p:clrMapOvr>
-</p:sld>
-</file>
-
-<file path=ppt/slides/slide8.xml><?xml version="1.0" encoding="utf-8"?>
-<p:sld xmlns:a="http://schemas.openxmlformats.org/drawingml/2006/main" xmlns:p="http://schemas.openxmlformats.org/presentationml/2006/main" xmlns:r="http://schemas.openxmlformats.org/officeDocument/2006/relationships">
-  <p:cSld>
-    <p:spTree>
-      <p:nvGrpSpPr>
-        <p:cNvPr id="1" name=""/>
-        <p:cNvGrpSpPr/>
-        <p:nvPr/>
-      </p:nvGrpSpPr>
-      <p:grpSpPr/>
-      <p:sp>
-        <p:nvSpPr>
-          <p:cNvPr id="2" name="TextBox 1"/>
-          <p:cNvSpPr txBox="1"/>
-          <p:nvPr/>
-        </p:nvSpPr>
-        <p:spPr>
-          <a:xfrm>
-            <a:off x="457200" y="228600"/>
-            <a:ext cx="11247120" cy="640080"/>
-          </a:xfrm>
-          <a:prstGeom prst="rect">
-            <a:avLst/>
-          </a:prstGeom>
-          <a:noFill/>
-        </p:spPr>
-        <p:txBody>
-          <a:bodyPr wrap="none">
-            <a:spAutoFit/>
-          </a:bodyPr>
-          <a:lstStyle/>
-          <a:p>
-            <a:pPr>
-              <a:defRPr sz="2800" b="1">
-                <a:solidFill>
-                  <a:srgbClr val="1F4E79"/>
-                </a:solidFill>
-              </a:defRPr>
-            </a:pPr>
-            <a:r>
-              <a:t>What — bundle</a:t>
-            </a:r>
-          </a:p>
-        </p:txBody>
-      </p:sp>
-      <p:pic>
-        <p:nvPicPr>
-          <p:cNvPr id="3" name="Picture 2" descr="nb_bundle_churn_all.png"/>
-          <p:cNvPicPr>
-            <a:picLocks noChangeAspect="1"/>
-          </p:cNvPicPr>
-          <p:nvPr/>
-        </p:nvPicPr>
-        <p:blipFill>
-          <a:blip r:embed="rId2"/>
-          <a:stretch>
-            <a:fillRect/>
-          </a:stretch>
-        </p:blipFill>
-        <p:spPr>
-          <a:xfrm>
-            <a:off x="365760" y="1005840"/>
-            <a:ext cx="6583680" cy="4071048"/>
-          </a:xfrm>
-          <a:prstGeom prst="rect">
-            <a:avLst/>
-          </a:prstGeom>
-        </p:spPr>
-      </p:pic>
-      <p:sp>
-        <p:nvSpPr>
-          <p:cNvPr id="4" name="TextBox 3"/>
-          <p:cNvSpPr txBox="1"/>
-          <p:nvPr/>
-        </p:nvSpPr>
-        <p:spPr>
-          <a:xfrm>
-            <a:off x="7132320" y="1188720"/>
-            <a:ext cx="4572000" cy="5394960"/>
-          </a:xfrm>
-          <a:prstGeom prst="rect">
-            <a:avLst/>
-          </a:prstGeom>
-          <a:noFill/>
-        </p:spPr>
-        <p:txBody>
-          <a:bodyPr wrap="square">
-            <a:spAutoFit/>
-          </a:bodyPr>
-          <a:lstStyle/>
-          <a:p>
-            <a:pPr>
-              <a:spcAft>
-                <a:spcPts val="1000"/>
-              </a:spcAft>
-            </a:pPr>
-            <a:r>
-              <a:rPr sz="1300" b="1">
-                <a:solidFill>
-                  <a:srgbClr val="1F4E79"/>
-                </a:solidFill>
-              </a:rPr>
-              <a:t>•  50Mb entry tier churns most</a:t>
-            </a:r>
-            <a:r>
-              <a:rPr sz="1300" b="0">
-                <a:solidFill>
-                  <a:srgbClr val="222222"/>
-                </a:solidFill>
-              </a:rPr>
-              <a:t>  —  82.0% (n=1,030; OR 1.39 vs 150Mb) — price-sensitive or underserved entry customers.</a:t>
-            </a:r>
-          </a:p>
-          <a:p>
-            <a:pPr>
-              <a:spcAft>
-                <a:spcPts val="1000"/>
-              </a:spcAft>
-            </a:pPr>
-            <a:r>
-              <a:rPr sz="1300" b="1">
-                <a:solidFill>
-                  <a:srgbClr val="1F4E79"/>
-                </a:solidFill>
-              </a:rPr>
-              <a:t>•  Mid/high tiers churn less</a:t>
-            </a:r>
-            <a:r>
-              <a:rPr sz="1300" b="0">
-                <a:solidFill>
-                  <a:srgbClr val="222222"/>
-                </a:solidFill>
-              </a:rPr>
-              <a:t>  —  500Mb 67%, 1Gb 66%; 'Other' niche bundles show the lowest recorded churn (small n).</a:t>
-            </a:r>
-          </a:p>
-          <a:p>
-            <a:pPr>
-              <a:spcAft>
-                <a:spcPts val="1000"/>
-              </a:spcAft>
-            </a:pPr>
-            <a:r>
-              <a:rPr sz="1300" b="1">
-                <a:solidFill>
-                  <a:srgbClr val="1F4E79"/>
-                </a:solidFill>
-              </a:rPr>
-              <a:t>•  Action</a:t>
-            </a:r>
-            <a:r>
-              <a:rPr sz="1300" b="0">
-                <a:solidFill>
-                  <a:srgbClr val="222222"/>
-                </a:solidFill>
-              </a:rPr>
-              <a:t>  —  an upgrade path for the entry tier is cheaper than acquiring replacements.</a:t>
-            </a:r>
-          </a:p>
-        </p:txBody>
-      </p:sp>
-    </p:spTree>
-  </p:cSld>
-  <p:clrMapOvr>
-    <a:masterClrMapping/>
-  </p:clrMapOvr>
-</p:sld>
-</file>
-
-<file path=ppt/slides/slide9.xml><?xml version="1.0" encoding="utf-8"?>
-<p:sld xmlns:a="http://schemas.openxmlformats.org/drawingml/2006/main" xmlns:p="http://schemas.openxmlformats.org/presentationml/2006/main" xmlns:r="http://schemas.openxmlformats.org/officeDocument/2006/relationships">
-  <p:cSld>
-    <p:spTree>
-      <p:nvGrpSpPr>
-        <p:cNvPr id="1" name=""/>
-        <p:cNvGrpSpPr/>
-        <p:nvPr/>
-      </p:nvGrpSpPr>
-      <p:grpSpPr/>
-      <p:sp>
-        <p:nvSpPr>
-          <p:cNvPr id="2" name="TextBox 1"/>
-          <p:cNvSpPr txBox="1"/>
-          <p:nvPr/>
-        </p:nvSpPr>
-        <p:spPr>
-          <a:xfrm>
-            <a:off x="457200" y="228600"/>
-            <a:ext cx="11247120" cy="640080"/>
-          </a:xfrm>
-          <a:prstGeom prst="rect">
-            <a:avLst/>
-          </a:prstGeom>
-          <a:noFill/>
-        </p:spPr>
-        <p:txBody>
-          <a:bodyPr wrap="none">
-            <a:spAutoFit/>
-          </a:bodyPr>
-          <a:lstStyle/>
-          <a:p>
-            <a:pPr>
-              <a:defRPr sz="2800" b="1">
-                <a:solidFill>
-                  <a:srgbClr val="1F4E79"/>
-                </a:solidFill>
-              </a:defRPr>
-            </a:pPr>
-            <a:r>
-              <a:t>When customers leave — timing</a:t>
-            </a:r>
-          </a:p>
-        </p:txBody>
-      </p:sp>
-      <p:pic>
-        <p:nvPicPr>
-          <p:cNvPr id="3" name="Picture 2" descr="nb_monthly_churn.png"/>
-          <p:cNvPicPr>
-            <a:picLocks noChangeAspect="1"/>
-          </p:cNvPicPr>
-          <p:nvPr/>
-        </p:nvPicPr>
-        <p:blipFill>
-          <a:blip r:embed="rId2"/>
-          <a:stretch>
-            <a:fillRect/>
-          </a:stretch>
-        </p:blipFill>
-        <p:spPr>
-          <a:xfrm>
-            <a:off x="365760" y="914400"/>
-            <a:ext cx="5852160" cy="2438400"/>
-          </a:xfrm>
-          <a:prstGeom prst="rect">
-            <a:avLst/>
-          </a:prstGeom>
-        </p:spPr>
-      </p:pic>
-      <p:pic>
-        <p:nvPicPr>
-          <p:cNvPr id="4" name="Picture 3" descr="nb_tenure_hist.png"/>
-          <p:cNvPicPr>
-            <a:picLocks noChangeAspect="1"/>
-          </p:cNvPicPr>
-          <p:nvPr/>
-        </p:nvPicPr>
-        <p:blipFill>
-          <a:blip r:embed="rId3"/>
-          <a:stretch>
-            <a:fillRect/>
-          </a:stretch>
-        </p:blipFill>
-        <p:spPr>
-          <a:xfrm>
-            <a:off x="6309360" y="914400"/>
-            <a:ext cx="5669280" cy="3401568"/>
-          </a:xfrm>
-          <a:prstGeom prst="rect">
-            <a:avLst/>
-          </a:prstGeom>
-        </p:spPr>
-      </p:pic>
-      <p:sp>
-        <p:nvSpPr>
-          <p:cNvPr id="5" name="TextBox 4"/>
-          <p:cNvSpPr txBox="1"/>
-          <p:nvPr/>
-        </p:nvSpPr>
-        <p:spPr>
-          <a:xfrm>
-            <a:off x="457200" y="4114800"/>
+            <a:off x="457200" y="1051560"/>
             <a:ext cx="11247120" cy="5394960"/>
           </a:xfrm>
           <a:prstGeom prst="rect">
@@ -5364,7 +4248,7 @@
           <a:p>
             <a:pPr>
               <a:spcAft>
-                <a:spcPts val="1000"/>
+                <a:spcPts val="900"/>
               </a:spcAft>
             </a:pPr>
             <a:r>
@@ -5373,7 +4257,7 @@
                   <a:srgbClr val="1F4E79"/>
                 </a:solidFill>
               </a:rPr>
-              <a:t>•  Churn concentrates around contract end</a:t>
+              <a:t>•  Altnet overbuild</a:t>
             </a:r>
             <a:r>
               <a:rPr sz="1300" b="0">
@@ -5381,13 +4265,13 @@
                   <a:srgbClr val="222222"/>
                 </a:solidFill>
               </a:rPr>
-              <a:t>  —  median churned tenure ≈ 12 months; the &lt;6-month bands showing 100% are an observation artifact (active customers can't yet appear there) — though ~1,070 real early churners still warrant onboarding attention.</a:t>
+              <a:t>  —  UK altnets (incl. Hyperoptic) often overbuilt the same dense postcodes — when a mover's new address sits on another network, churn is automatic, not competitive loss. This matches our data: mover-dominated reasons + competitors not significant.</a:t>
             </a:r>
           </a:p>
           <a:p>
             <a:pPr>
               <a:spcAft>
-                <a:spcPts val="1000"/>
+                <a:spcPts val="900"/>
               </a:spcAft>
             </a:pPr>
             <a:r>
@@ -5396,7 +4280,7 @@
                   <a:srgbClr val="1F4E79"/>
                 </a:solidFill>
               </a:rPr>
-              <a:t>•  Cohort rates reflect exposure</a:t>
+              <a:t>•  Price pressure &amp; consolidation</a:t>
             </a:r>
             <a:r>
               <a:rPr sz="1300" b="0">
@@ -5404,13 +4288,13 @@
                   <a:srgbClr val="222222"/>
                 </a:solidFill>
               </a:rPr>
-              <a:t>  —  2024's 37% is mostly less time to churn, not better retention — report on a survival basis.</a:t>
+              <a:t>  —  wholesale FTTP prices fell ~40% in real terms; altnets are consolidating — retaining existing customers beats the market's rising acquisition costs.</a:t>
             </a:r>
           </a:p>
           <a:p>
             <a:pPr>
               <a:spcAft>
-                <a:spcPts val="1000"/>
+                <a:spcPts val="900"/>
               </a:spcAft>
             </a:pPr>
             <a:r>
@@ -5419,7 +4303,7 @@
                   <a:srgbClr val="1F4E79"/>
                 </a:solidFill>
               </a:rPr>
-              <a:t>•  Same-day terminations</a:t>
+              <a:t>•  1. Contract migration</a:t>
             </a:r>
             <a:r>
               <a:rPr sz="1300" b="0">
@@ -5427,7 +4311,76 @@
                   <a:srgbClr val="222222"/>
                 </a:solidFill>
               </a:rPr>
-              <a:t>  —  28 customers left on activation day — worth an order-flow check.</a:t>
+              <a:t>  —  move monthly/12-month customers to 24-month terms at renewal (OR 0.22 — biggest controllable effect).</a:t>
+            </a:r>
+          </a:p>
+          <a:p>
+            <a:pPr>
+              <a:spcAft>
+                <a:spcPts val="900"/>
+              </a:spcAft>
+            </a:pPr>
+            <a:r>
+              <a:rPr sz="1300" b="1">
+                <a:solidFill>
+                  <a:srgbClr val="1F4E79"/>
+                </a:solidFill>
+              </a:rPr>
+              <a:t>•  2. Mover's programme</a:t>
+            </a:r>
+            <a:r>
+              <a:rPr sz="1300" b="0">
+                <a:solidFill>
+                  <a:srgbClr val="222222"/>
+                </a:solidFill>
+              </a:rPr>
+              <a:t>  —  seamless home-move transfers + landlord/developer partnerships for the 82% who relocate.</a:t>
+            </a:r>
+          </a:p>
+          <a:p>
+            <a:pPr>
+              <a:spcAft>
+                <a:spcPts val="900"/>
+              </a:spcAft>
+            </a:pPr>
+            <a:r>
+              <a:rPr sz="1300" b="1">
+                <a:solidFill>
+                  <a:srgbClr val="1F4E79"/>
+                </a:solidFill>
+              </a:rPr>
+              <a:t>•  3. Manchester &amp; Leeds review</a:t>
+            </a:r>
+            <a:r>
+              <a:rPr sz="1300" b="0">
+                <a:solidFill>
+                  <a:srgbClr val="222222"/>
+                </a:solidFill>
+              </a:rPr>
+              <a:t>  —  local service quality, install experience, overbuild pressure.</a:t>
+            </a:r>
+          </a:p>
+          <a:p>
+            <a:pPr>
+              <a:spcAft>
+                <a:spcPts val="900"/>
+              </a:spcAft>
+            </a:pPr>
+            <a:r>
+              <a:rPr sz="1300" b="1">
+                <a:solidFill>
+                  <a:srgbClr val="1F4E79"/>
+                </a:solidFill>
+              </a:rPr>
+              <a:t>•  4. Entry-tier upgrade path</a:t>
+            </a:r>
+            <a:r>
+              <a:rPr sz="1300" b="0">
+                <a:solidFill>
+                  <a:srgbClr val="222222"/>
+                </a:solidFill>
+              </a:rPr>
+              <a:t>  —  50Mb churns most (82%) — nudge toward higher tiers; deploy the model in CRM to score active customers; report churn on a survival basis.</a:t>
             </a:r>
           </a:p>
         </p:txBody>

</xml_diff>

<commit_message>
Cite sources on the UK market slide
- Slide 5 claims now tied to sources: Cartesian 'The State of UK Fibre'
  (47% of UK has >1 FTTP network; consolidation needed), INCA/Point Topic
  'State of the Altnets' (entry FTTP £22->£19 2020-25; overbuild a rising
  altnet concern), Ofcom copper switchover
- Sources footnote added at the bottom of the slide

Co-Authored-By: Devin AI <158243242+devin-ai-integration[bot]@users.noreply.github.com>
</commit_message>
<xml_diff>
--- a/presentation/Churn_Analysis_Final.pptx
+++ b/presentation/Churn_Analysis_Final.pptx
@@ -4232,8 +4232,8 @@
         </p:nvSpPr>
         <p:spPr>
           <a:xfrm>
-            <a:off x="457200" y="1051560"/>
-            <a:ext cx="11247120" cy="5394960"/>
+            <a:off x="457200" y="914400"/>
+            <a:ext cx="11247120" cy="5120640"/>
           </a:xfrm>
           <a:prstGeom prst="rect">
             <a:avLst/>
@@ -4252,7 +4252,7 @@
               </a:spcAft>
             </a:pPr>
             <a:r>
-              <a:rPr sz="1300" b="1">
+              <a:rPr sz="1200" b="1">
                 <a:solidFill>
                   <a:srgbClr val="1F4E79"/>
                 </a:solidFill>
@@ -4260,12 +4260,12 @@
               <a:t>•  Altnet overbuild</a:t>
             </a:r>
             <a:r>
-              <a:rPr sz="1300" b="0">
+              <a:rPr sz="1200" b="0">
                 <a:solidFill>
                   <a:srgbClr val="222222"/>
                 </a:solidFill>
               </a:rPr>
-              <a:t>  —  UK altnets (incl. Hyperoptic) often overbuilt the same dense postcodes — when a mover's new address sits on another network, churn is automatic, not competitive loss. This matches our data: mover-dominated reasons + competitors not significant.</a:t>
+              <a:t>  —  47% of the UK now has more than one FTTP network (Cartesian); altnets report overbuild by other altnets as a sharply rising challenge (INCA). When a mover's new address sits on another network, churn is automatic, not competitive loss — matching our data: mover-dominated reasons + competitors not significant.</a:t>
             </a:r>
           </a:p>
           <a:p>
@@ -4275,7 +4275,7 @@
               </a:spcAft>
             </a:pPr>
             <a:r>
-              <a:rPr sz="1300" b="1">
+              <a:rPr sz="1200" b="1">
                 <a:solidFill>
                   <a:srgbClr val="1F4E79"/>
                 </a:solidFill>
@@ -4283,12 +4283,12 @@
               <a:t>•  Price pressure &amp; consolidation</a:t>
             </a:r>
             <a:r>
-              <a:rPr sz="1300" b="0">
+              <a:rPr sz="1200" b="0">
                 <a:solidFill>
                   <a:srgbClr val="222222"/>
                 </a:solidFill>
               </a:rPr>
-              <a:t>  —  wholesale FTTP prices fell ~40% in real terms; altnets are consolidating — retaining existing customers beats the market's rising acquisition costs.</a:t>
+              <a:t>  —  entry-level altnet FTTP prices fell £22 → £19 (2020–25), well below BT's £35 (INCA); Cartesian calls pricing 'very aggressive' and consolidation needed for economies of scale — retaining customers beats rising acquisition costs.</a:t>
             </a:r>
           </a:p>
           <a:p>
@@ -4298,7 +4298,7 @@
               </a:spcAft>
             </a:pPr>
             <a:r>
-              <a:rPr sz="1300" b="1">
+              <a:rPr sz="1200" b="1">
                 <a:solidFill>
                   <a:srgbClr val="1F4E79"/>
                 </a:solidFill>
@@ -4306,7 +4306,7 @@
               <a:t>•  1. Contract migration</a:t>
             </a:r>
             <a:r>
-              <a:rPr sz="1300" b="0">
+              <a:rPr sz="1200" b="0">
                 <a:solidFill>
                   <a:srgbClr val="222222"/>
                 </a:solidFill>
@@ -4321,7 +4321,7 @@
               </a:spcAft>
             </a:pPr>
             <a:r>
-              <a:rPr sz="1300" b="1">
+              <a:rPr sz="1200" b="1">
                 <a:solidFill>
                   <a:srgbClr val="1F4E79"/>
                 </a:solidFill>
@@ -4329,7 +4329,7 @@
               <a:t>•  2. Mover's programme</a:t>
             </a:r>
             <a:r>
-              <a:rPr sz="1300" b="0">
+              <a:rPr sz="1200" b="0">
                 <a:solidFill>
                   <a:srgbClr val="222222"/>
                 </a:solidFill>
@@ -4344,7 +4344,7 @@
               </a:spcAft>
             </a:pPr>
             <a:r>
-              <a:rPr sz="1300" b="1">
+              <a:rPr sz="1200" b="1">
                 <a:solidFill>
                   <a:srgbClr val="1F4E79"/>
                 </a:solidFill>
@@ -4352,7 +4352,7 @@
               <a:t>•  3. Manchester &amp; Leeds review</a:t>
             </a:r>
             <a:r>
-              <a:rPr sz="1300" b="0">
+              <a:rPr sz="1200" b="0">
                 <a:solidFill>
                   <a:srgbClr val="222222"/>
                 </a:solidFill>
@@ -4367,7 +4367,7 @@
               </a:spcAft>
             </a:pPr>
             <a:r>
-              <a:rPr sz="1300" b="1">
+              <a:rPr sz="1200" b="1">
                 <a:solidFill>
                   <a:srgbClr val="1F4E79"/>
                 </a:solidFill>
@@ -4375,12 +4375,47 @@
               <a:t>•  4. Entry-tier upgrade path</a:t>
             </a:r>
             <a:r>
-              <a:rPr sz="1300" b="0">
+              <a:rPr sz="1200" b="0">
                 <a:solidFill>
                   <a:srgbClr val="222222"/>
                 </a:solidFill>
               </a:rPr>
               <a:t>  —  50Mb churns most (82%) — nudge toward higher tiers; deploy the model in CRM to score active customers; report churn on a survival basis.</a:t>
+            </a:r>
+          </a:p>
+        </p:txBody>
+      </p:sp>
+      <p:sp>
+        <p:nvSpPr>
+          <p:cNvPr id="4" name="TextBox 3"/>
+          <p:cNvSpPr txBox="1"/>
+          <p:nvPr/>
+        </p:nvSpPr>
+        <p:spPr>
+          <a:xfrm>
+            <a:off x="457200" y="6172200"/>
+            <a:ext cx="11338560" cy="640080"/>
+          </a:xfrm>
+          <a:prstGeom prst="rect">
+            <a:avLst/>
+          </a:prstGeom>
+          <a:noFill/>
+        </p:spPr>
+        <p:txBody>
+          <a:bodyPr wrap="square">
+            <a:spAutoFit/>
+          </a:bodyPr>
+          <a:lstStyle/>
+          <a:p>
+            <a:pPr>
+              <a:defRPr sz="900">
+                <a:solidFill>
+                  <a:srgbClr val="808080"/>
+                </a:solidFill>
+              </a:defRPr>
+            </a:pPr>
+            <a:r>
+              <a:t>Sources: Cartesian, 'The State of UK Fibre' (2025) — cartesian.com/state-of-uk-fibre · INCA &amp; Point Topic, 'State of the Altnets' annual report — inca.coop · Ofcom, Telecoms Access Review / copper switchover proposals · Internal dataset: Case_Study_Data_1.xlsx (10,000 customers).</a:t>
             </a:r>
           </a:p>
         </p:txBody>

</xml_diff>